<commit_message>
Reframe workshop as a two-session comparison
</commit_message>
<xml_diff>
--- a/deck_update/outputs/Claude_Code_Efficiency_Workshop_Sandbox.pptx
+++ b/deck_update/outputs/Claude_Code_Efficiency_Workshop_Sandbox.pptx
@@ -2,31 +2,31 @@
 <file path=ppt/presentation.xml><?xml version="1.0" encoding="utf-8"?>
 <p:presentation xmlns:p="http://schemas.openxmlformats.org/presentationml/2006/main">
   <p:sldMasterIdLst>
-    <p:sldMasterId xmlns:r="http://schemas.openxmlformats.org/officeDocument/2006/relationships" id="2147483648" r:id="R7ff3f8e4792e4975"/>
+    <p:sldMasterId xmlns:r="http://schemas.openxmlformats.org/officeDocument/2006/relationships" id="2147483648" r:id="R8ad44a01590e4a99"/>
   </p:sldMasterIdLst>
   <p:notesMasterIdLst>
-    <p:notesMasterId xmlns:r="http://schemas.openxmlformats.org/officeDocument/2006/relationships" r:id="Rb0aeb0e9fa51498a"/>
+    <p:notesMasterId xmlns:r="http://schemas.openxmlformats.org/officeDocument/2006/relationships" r:id="Rfb70e22cd9eb4900"/>
   </p:notesMasterIdLst>
   <p:sldIdLst>
-    <p:sldId xmlns:r="http://schemas.openxmlformats.org/officeDocument/2006/relationships" id="256" r:id="R7c08d85270f94e6d"/>
-    <p:sldId xmlns:r="http://schemas.openxmlformats.org/officeDocument/2006/relationships" id="257" r:id="Ra9b0a7ba296c49de"/>
-    <p:sldId xmlns:r="http://schemas.openxmlformats.org/officeDocument/2006/relationships" id="258" r:id="R32ebaa0282c84f46"/>
-    <p:sldId xmlns:r="http://schemas.openxmlformats.org/officeDocument/2006/relationships" id="259" r:id="R602d172e225d4270"/>
-    <p:sldId xmlns:r="http://schemas.openxmlformats.org/officeDocument/2006/relationships" id="260" r:id="Rfcffa3d09851414e"/>
-    <p:sldId xmlns:r="http://schemas.openxmlformats.org/officeDocument/2006/relationships" id="261" r:id="Re52f6eac11bc46a2"/>
-    <p:sldId xmlns:r="http://schemas.openxmlformats.org/officeDocument/2006/relationships" id="262" r:id="R99c22a9a86d94aba"/>
-    <p:sldId xmlns:r="http://schemas.openxmlformats.org/officeDocument/2006/relationships" id="263" r:id="R494a6e40dfd34073"/>
-    <p:sldId xmlns:r="http://schemas.openxmlformats.org/officeDocument/2006/relationships" id="264" r:id="R5eefadd58e224616"/>
-    <p:sldId xmlns:r="http://schemas.openxmlformats.org/officeDocument/2006/relationships" id="265" r:id="R8a7974b8c8264695"/>
-    <p:sldId xmlns:r="http://schemas.openxmlformats.org/officeDocument/2006/relationships" id="266" r:id="R8de1340c840649a7"/>
-    <p:sldId xmlns:r="http://schemas.openxmlformats.org/officeDocument/2006/relationships" id="267" r:id="R301efd72f39d461d"/>
-    <p:sldId xmlns:r="http://schemas.openxmlformats.org/officeDocument/2006/relationships" id="268" r:id="R559aea227c0d4df2"/>
-    <p:sldId xmlns:r="http://schemas.openxmlformats.org/officeDocument/2006/relationships" id="269" r:id="Rbce9d4ffab534bbd"/>
-    <p:sldId xmlns:r="http://schemas.openxmlformats.org/officeDocument/2006/relationships" id="270" r:id="R777837155a9348c7"/>
-    <p:sldId xmlns:r="http://schemas.openxmlformats.org/officeDocument/2006/relationships" id="271" r:id="R7c44d74717ba41bc"/>
-    <p:sldId xmlns:r="http://schemas.openxmlformats.org/officeDocument/2006/relationships" id="272" r:id="R3b33c2eea0304d41"/>
-    <p:sldId xmlns:r="http://schemas.openxmlformats.org/officeDocument/2006/relationships" id="273" r:id="R2cffd05ec527451a"/>
-    <p:sldId xmlns:r="http://schemas.openxmlformats.org/officeDocument/2006/relationships" id="274" r:id="R61b80d4773e64302"/>
+    <p:sldId xmlns:r="http://schemas.openxmlformats.org/officeDocument/2006/relationships" id="256" r:id="R96031770c3fa4b78"/>
+    <p:sldId xmlns:r="http://schemas.openxmlformats.org/officeDocument/2006/relationships" id="257" r:id="R5fecf9d98ad045c6"/>
+    <p:sldId xmlns:r="http://schemas.openxmlformats.org/officeDocument/2006/relationships" id="258" r:id="R825647059ce44f5c"/>
+    <p:sldId xmlns:r="http://schemas.openxmlformats.org/officeDocument/2006/relationships" id="259" r:id="Ra9d88399a5254413"/>
+    <p:sldId xmlns:r="http://schemas.openxmlformats.org/officeDocument/2006/relationships" id="260" r:id="R25fb75e2be954134"/>
+    <p:sldId xmlns:r="http://schemas.openxmlformats.org/officeDocument/2006/relationships" id="261" r:id="R31b4871c73f24e58"/>
+    <p:sldId xmlns:r="http://schemas.openxmlformats.org/officeDocument/2006/relationships" id="262" r:id="R280650cc49c543bc"/>
+    <p:sldId xmlns:r="http://schemas.openxmlformats.org/officeDocument/2006/relationships" id="263" r:id="R66e42f1582ea4b2c"/>
+    <p:sldId xmlns:r="http://schemas.openxmlformats.org/officeDocument/2006/relationships" id="264" r:id="R228b741a97b84bf6"/>
+    <p:sldId xmlns:r="http://schemas.openxmlformats.org/officeDocument/2006/relationships" id="265" r:id="R8b66233b7f884bc7"/>
+    <p:sldId xmlns:r="http://schemas.openxmlformats.org/officeDocument/2006/relationships" id="266" r:id="R6f660604bfad4d91"/>
+    <p:sldId xmlns:r="http://schemas.openxmlformats.org/officeDocument/2006/relationships" id="267" r:id="Ra1d2c43add6f4967"/>
+    <p:sldId xmlns:r="http://schemas.openxmlformats.org/officeDocument/2006/relationships" id="268" r:id="R1d2e86e89f7d4e49"/>
+    <p:sldId xmlns:r="http://schemas.openxmlformats.org/officeDocument/2006/relationships" id="269" r:id="Re73d72bce96f4bec"/>
+    <p:sldId xmlns:r="http://schemas.openxmlformats.org/officeDocument/2006/relationships" id="270" r:id="Rd0b046c9bd0840a9"/>
+    <p:sldId xmlns:r="http://schemas.openxmlformats.org/officeDocument/2006/relationships" id="271" r:id="Ra8e81e8eb59f4da6"/>
+    <p:sldId xmlns:r="http://schemas.openxmlformats.org/officeDocument/2006/relationships" id="272" r:id="R39a2b339dfb548c0"/>
+    <p:sldId xmlns:r="http://schemas.openxmlformats.org/officeDocument/2006/relationships" id="273" r:id="Rd82772517f924634"/>
+    <p:sldId xmlns:r="http://schemas.openxmlformats.org/officeDocument/2006/relationships" id="274" r:id="Rf5eadcdd4f3c4fe2"/>
   </p:sldIdLst>
   <p:sldSz cx="12192000" cy="6858000"/>
   <p:notesSz cx="6858000" cy="9144000"/>
@@ -875,7 +875,7 @@
           <a:lstStyle xmlns:a="http://schemas.openxmlformats.org/drawingml/2006/main"/>
           <a:p xmlns:a="http://schemas.openxmlformats.org/drawingml/2006/main">
             <a:r>
-              <a:t>Introduce the benchmark repo and explain why its shape makes prompt efficiency visible.</a:t>
+              <a:t>Introduce the benchmark repo and explain that session 1 creates context while session 2 reveals whether that context was reusable.</a:t>
             </a:r>
           </a:p>
         </p:txBody>
@@ -945,7 +945,7 @@
           <a:lstStyle xmlns:a="http://schemas.openxmlformats.org/drawingml/2006/main"/>
           <a:p xmlns:a="http://schemas.openxmlformats.org/drawingml/2006/main">
             <a:r>
-              <a:t>Use the scorecard before the live run so the audience understands the comparison criteria.</a:t>
+              <a:t>Use the scorecard before the live run so the audience understands that combined two-session efficiency matters more than a flashy first answer.</a:t>
             </a:r>
           </a:p>
         </p:txBody>
@@ -1015,7 +1015,7 @@
           <a:lstStyle xmlns:a="http://schemas.openxmlformats.org/drawingml/2006/main"/>
           <a:p xmlns:a="http://schemas.openxmlformats.org/drawingml/2006/main">
             <a:r>
-              <a:t>Turn the exercise into a repo-specific rewrite that mirrors the live implementation task.</a:t>
+              <a:t>Turn the exercise into a two-session rewrite so attendees practice prompting for reuse, not only for a one-off answer.</a:t>
             </a:r>
           </a:p>
         </p:txBody>
@@ -1800,8 +1800,8 @@
   </p:cSld>
   <p:clrMap bg1="lt1" tx1="dk1" bg2="lt2" tx2="dk2" accent1="accent1" accent2="accent2" accent3="accent3" accent4="accent4" accent5="accent5" accent6="accent6" hlink="hlink" folHlink="folHlink"/>
   <p:sldLayoutIdLst>
-    <p:sldLayoutId xmlns:r="http://schemas.openxmlformats.org/officeDocument/2006/relationships" id="2147483648" r:id="Rc9f3af2f1d174ed2"/>
-    <p:sldLayoutId xmlns:r="http://schemas.openxmlformats.org/officeDocument/2006/relationships" id="2147483649" r:id="R6c2ccd8b468e4e6b"/>
+    <p:sldLayoutId xmlns:r="http://schemas.openxmlformats.org/officeDocument/2006/relationships" id="2147483648" r:id="R597be376ce6d4d87"/>
+    <p:sldLayoutId xmlns:r="http://schemas.openxmlformats.org/officeDocument/2006/relationships" id="2147483649" r:id="Re53e6466f3184770"/>
   </p:sldLayoutIdLst>
   <p:txStyles>
     <p:titleStyle>
@@ -2077,7 +2077,7 @@
           <p:cNvPr id="2" name="Shape 0">
             <a:extLst xmlns:a="http://schemas.openxmlformats.org/drawingml/2006/main">
               <a:ext uri="{FF2B5EF4-FFF2-40B4-BE49-F238E27FC236}">
-                <a16:creationId xmlns:a16="http://schemas.microsoft.com/office/drawing/2014/main" id="{D397EB49-4C1E-4A0D-88CB-2CC0B0DEFEDA}"/>
+                <a16:creationId xmlns:a16="http://schemas.microsoft.com/office/drawing/2014/main" id="{B0E6927E-97F6-4CA9-A956-46133B5991B0}"/>
               </a:ext>
             </a:extLst>
           </p:cNvPr>
@@ -2110,7 +2110,7 @@
           <p:cNvPr id="3" name="Text 1">
             <a:extLst xmlns:a="http://schemas.openxmlformats.org/drawingml/2006/main">
               <a:ext uri="{FF2B5EF4-FFF2-40B4-BE49-F238E27FC236}">
-                <a16:creationId xmlns:a16="http://schemas.microsoft.com/office/drawing/2014/main" id="{45BFA014-22C7-462E-88F2-A0278C5F94D9}"/>
+                <a16:creationId xmlns:a16="http://schemas.microsoft.com/office/drawing/2014/main" id="{3C8A6B1C-DCE2-4C70-B541-E4DBB84B5F06}"/>
               </a:ext>
             </a:extLst>
           </p:cNvPr>
@@ -2157,7 +2157,7 @@
           <p:cNvPr id="4" name="Text 2">
             <a:extLst xmlns:a="http://schemas.openxmlformats.org/drawingml/2006/main">
               <a:ext uri="{FF2B5EF4-FFF2-40B4-BE49-F238E27FC236}">
-                <a16:creationId xmlns:a16="http://schemas.microsoft.com/office/drawing/2014/main" id="{BDDA9EF4-A0BC-4276-8517-6523C55CAD00}"/>
+                <a16:creationId xmlns:a16="http://schemas.microsoft.com/office/drawing/2014/main" id="{A7F3158D-45B6-4EFE-A15E-31D7090F2CDC}"/>
               </a:ext>
             </a:extLst>
           </p:cNvPr>
@@ -2204,7 +2204,7 @@
           <p:cNvPr id="5" name="Text 3">
             <a:extLst xmlns:a="http://schemas.openxmlformats.org/drawingml/2006/main">
               <a:ext uri="{FF2B5EF4-FFF2-40B4-BE49-F238E27FC236}">
-                <a16:creationId xmlns:a16="http://schemas.microsoft.com/office/drawing/2014/main" id="{031D4D77-FD0D-4B07-AD52-8A548FA626E1}"/>
+                <a16:creationId xmlns:a16="http://schemas.microsoft.com/office/drawing/2014/main" id="{33F67129-2C86-4788-800B-2F63FAE2BF45}"/>
               </a:ext>
             </a:extLst>
           </p:cNvPr>
@@ -2279,7 +2279,7 @@
           <p:cNvPr id="6" name="Text 4">
             <a:extLst xmlns:a="http://schemas.openxmlformats.org/drawingml/2006/main">
               <a:ext uri="{FF2B5EF4-FFF2-40B4-BE49-F238E27FC236}">
-                <a16:creationId xmlns:a16="http://schemas.microsoft.com/office/drawing/2014/main" id="{75EDD869-63ED-47AB-8C24-C12510DBD578}"/>
+                <a16:creationId xmlns:a16="http://schemas.microsoft.com/office/drawing/2014/main" id="{95A99FD5-7F88-4934-88D3-0C8FBD1CB1A8}"/>
               </a:ext>
             </a:extLst>
           </p:cNvPr>
@@ -2354,7 +2354,7 @@
           <p:cNvPr id="7" name="Text 5">
             <a:extLst xmlns:a="http://schemas.openxmlformats.org/drawingml/2006/main">
               <a:ext uri="{FF2B5EF4-FFF2-40B4-BE49-F238E27FC236}">
-                <a16:creationId xmlns:a16="http://schemas.microsoft.com/office/drawing/2014/main" id="{2D445ADF-824A-40B0-985F-BDCDC17FECCA}"/>
+                <a16:creationId xmlns:a16="http://schemas.microsoft.com/office/drawing/2014/main" id="{352F8E5C-11A2-4E64-A4A6-6296275745C6}"/>
               </a:ext>
             </a:extLst>
           </p:cNvPr>
@@ -2399,7 +2399,7 @@
     </p:spTree>
     <p:extLst>
       <p:ext uri="{BB962C8B-B14F-4D97-AF65-F5344CB8AC3E}">
-        <p14:creationId xmlns:p14="http://schemas.microsoft.com/office/powerpoint/2010/main" val="1518636750"/>
+        <p14:creationId xmlns:p14="http://schemas.microsoft.com/office/powerpoint/2010/main" val="1892134048"/>
       </p:ext>
     </p:extLst>
   </p:cSld>
@@ -2430,7 +2430,7 @@
           <p:cNvPr id="2" name="Shape 0">
             <a:extLst xmlns:a="http://schemas.openxmlformats.org/drawingml/2006/main">
               <a:ext uri="{FF2B5EF4-FFF2-40B4-BE49-F238E27FC236}">
-                <a16:creationId xmlns:a16="http://schemas.microsoft.com/office/drawing/2014/main" id="{821CAD2E-3ED3-4F77-8912-399EB892F0D4}"/>
+                <a16:creationId xmlns:a16="http://schemas.microsoft.com/office/drawing/2014/main" id="{59AC09A9-A12D-45B9-9596-A8C3CD7AF6E8}"/>
               </a:ext>
             </a:extLst>
           </p:cNvPr>
@@ -2463,7 +2463,7 @@
           <p:cNvPr id="3" name="Text 1">
             <a:extLst xmlns:a="http://schemas.openxmlformats.org/drawingml/2006/main">
               <a:ext uri="{FF2B5EF4-FFF2-40B4-BE49-F238E27FC236}">
-                <a16:creationId xmlns:a16="http://schemas.microsoft.com/office/drawing/2014/main" id="{BB3E7B05-2907-42B2-9915-AA7B8A888298}"/>
+                <a16:creationId xmlns:a16="http://schemas.microsoft.com/office/drawing/2014/main" id="{1A688837-293B-4C4B-9414-274720E498E6}"/>
               </a:ext>
             </a:extLst>
           </p:cNvPr>
@@ -2510,7 +2510,7 @@
           <p:cNvPr id="4" name="Text 2">
             <a:extLst xmlns:a="http://schemas.openxmlformats.org/drawingml/2006/main">
               <a:ext uri="{FF2B5EF4-FFF2-40B4-BE49-F238E27FC236}">
-                <a16:creationId xmlns:a16="http://schemas.microsoft.com/office/drawing/2014/main" id="{9D1CE612-F254-40E6-94EA-D241C50D77E1}"/>
+                <a16:creationId xmlns:a16="http://schemas.microsoft.com/office/drawing/2014/main" id="{1CDF0D28-F65B-44B5-87FC-A971851020B1}"/>
               </a:ext>
             </a:extLst>
           </p:cNvPr>
@@ -2557,7 +2557,7 @@
           <p:cNvPr id="5" name="Shape 3">
             <a:extLst xmlns:a="http://schemas.openxmlformats.org/drawingml/2006/main">
               <a:ext uri="{FF2B5EF4-FFF2-40B4-BE49-F238E27FC236}">
-                <a16:creationId xmlns:a16="http://schemas.microsoft.com/office/drawing/2014/main" id="{FF8D2180-A37D-43DB-BC39-DB63E9CC4C39}"/>
+                <a16:creationId xmlns:a16="http://schemas.microsoft.com/office/drawing/2014/main" id="{12D29116-2874-4929-925E-242A07956221}"/>
               </a:ext>
             </a:extLst>
           </p:cNvPr>
@@ -2588,7 +2588,7 @@
           <p:cNvPr id="6" name="Text 4">
             <a:extLst xmlns:a="http://schemas.openxmlformats.org/drawingml/2006/main">
               <a:ext uri="{FF2B5EF4-FFF2-40B4-BE49-F238E27FC236}">
-                <a16:creationId xmlns:a16="http://schemas.microsoft.com/office/drawing/2014/main" id="{06622170-46CF-4FF9-9857-3B8840691669}"/>
+                <a16:creationId xmlns:a16="http://schemas.microsoft.com/office/drawing/2014/main" id="{F852505C-C89A-4E8B-B537-049B25D7A27B}"/>
               </a:ext>
             </a:extLst>
           </p:cNvPr>
@@ -2727,7 +2727,7 @@
           <p:cNvPr id="7" name="Text 5">
             <a:extLst xmlns:a="http://schemas.openxmlformats.org/drawingml/2006/main">
               <a:ext uri="{FF2B5EF4-FFF2-40B4-BE49-F238E27FC236}">
-                <a16:creationId xmlns:a16="http://schemas.microsoft.com/office/drawing/2014/main" id="{8F3BD8D5-5A72-4768-8514-1E8A255E962A}"/>
+                <a16:creationId xmlns:a16="http://schemas.microsoft.com/office/drawing/2014/main" id="{2E69EBAF-2FED-4DAE-98D4-0EF1F4E3FB0B}"/>
               </a:ext>
             </a:extLst>
           </p:cNvPr>
@@ -2901,7 +2901,7 @@
     </p:spTree>
     <p:extLst>
       <p:ext uri="{BB962C8B-B14F-4D97-AF65-F5344CB8AC3E}">
-        <p14:creationId xmlns:p14="http://schemas.microsoft.com/office/powerpoint/2010/main" val="1926314825"/>
+        <p14:creationId xmlns:p14="http://schemas.microsoft.com/office/powerpoint/2010/main" val="2144182669"/>
       </p:ext>
     </p:extLst>
   </p:cSld>
@@ -2932,7 +2932,7 @@
           <p:cNvPr id="2" name="Shape 0">
             <a:extLst xmlns:a="http://schemas.openxmlformats.org/drawingml/2006/main">
               <a:ext uri="{FF2B5EF4-FFF2-40B4-BE49-F238E27FC236}">
-                <a16:creationId xmlns:a16="http://schemas.microsoft.com/office/drawing/2014/main" id="{505D7374-10BD-4348-8EA6-010669576CB7}"/>
+                <a16:creationId xmlns:a16="http://schemas.microsoft.com/office/drawing/2014/main" id="{EE7BD7EF-3E65-42ED-9E54-7D73285276FC}"/>
               </a:ext>
             </a:extLst>
           </p:cNvPr>
@@ -2965,7 +2965,7 @@
           <p:cNvPr id="3" name="Text 1">
             <a:extLst xmlns:a="http://schemas.openxmlformats.org/drawingml/2006/main">
               <a:ext uri="{FF2B5EF4-FFF2-40B4-BE49-F238E27FC236}">
-                <a16:creationId xmlns:a16="http://schemas.microsoft.com/office/drawing/2014/main" id="{B7400D25-8C51-4C3B-B6F0-96D15CE9400A}"/>
+                <a16:creationId xmlns:a16="http://schemas.microsoft.com/office/drawing/2014/main" id="{A0134A09-1923-4C6B-81EB-97DF030FE95E}"/>
               </a:ext>
             </a:extLst>
           </p:cNvPr>
@@ -3012,7 +3012,7 @@
           <p:cNvPr id="4" name="Text 2">
             <a:extLst xmlns:a="http://schemas.openxmlformats.org/drawingml/2006/main">
               <a:ext uri="{FF2B5EF4-FFF2-40B4-BE49-F238E27FC236}">
-                <a16:creationId xmlns:a16="http://schemas.microsoft.com/office/drawing/2014/main" id="{25C47EBF-10B3-4FC5-B192-4B3C0C46871B}"/>
+                <a16:creationId xmlns:a16="http://schemas.microsoft.com/office/drawing/2014/main" id="{E650B2AF-8FCC-4656-AD9E-53B6315C919A}"/>
               </a:ext>
             </a:extLst>
           </p:cNvPr>
@@ -3059,7 +3059,7 @@
           <p:cNvPr id="5" name="Shape 3">
             <a:extLst xmlns:a="http://schemas.openxmlformats.org/drawingml/2006/main">
               <a:ext uri="{FF2B5EF4-FFF2-40B4-BE49-F238E27FC236}">
-                <a16:creationId xmlns:a16="http://schemas.microsoft.com/office/drawing/2014/main" id="{7356216B-330D-4046-9193-E1E62EBDCB17}"/>
+                <a16:creationId xmlns:a16="http://schemas.microsoft.com/office/drawing/2014/main" id="{2326FAF2-E1E1-4A63-A0CC-0C6F63DA262A}"/>
               </a:ext>
             </a:extLst>
           </p:cNvPr>
@@ -3090,7 +3090,7 @@
           <p:cNvPr id="6" name="Text 4">
             <a:extLst xmlns:a="http://schemas.openxmlformats.org/drawingml/2006/main">
               <a:ext uri="{FF2B5EF4-FFF2-40B4-BE49-F238E27FC236}">
-                <a16:creationId xmlns:a16="http://schemas.microsoft.com/office/drawing/2014/main" id="{7B8FD125-0C94-4E18-A527-5E5F6FB6D1D2}"/>
+                <a16:creationId xmlns:a16="http://schemas.microsoft.com/office/drawing/2014/main" id="{5328186F-B845-4582-80A7-B80530C47DED}"/>
               </a:ext>
             </a:extLst>
           </p:cNvPr>
@@ -3213,7 +3213,7 @@
           <p:cNvPr id="7" name="Text 5">
             <a:extLst xmlns:a="http://schemas.openxmlformats.org/drawingml/2006/main">
               <a:ext uri="{FF2B5EF4-FFF2-40B4-BE49-F238E27FC236}">
-                <a16:creationId xmlns:a16="http://schemas.microsoft.com/office/drawing/2014/main" id="{DD3C5E3B-D705-401C-BBC9-0ABB03139BB5}"/>
+                <a16:creationId xmlns:a16="http://schemas.microsoft.com/office/drawing/2014/main" id="{6DDC8A5D-B6F6-4B4F-A631-A2DD6D1B7A0D}"/>
               </a:ext>
             </a:extLst>
           </p:cNvPr>
@@ -3323,7 +3323,7 @@
     </p:spTree>
     <p:extLst>
       <p:ext uri="{BB962C8B-B14F-4D97-AF65-F5344CB8AC3E}">
-        <p14:creationId xmlns:p14="http://schemas.microsoft.com/office/powerpoint/2010/main" val="612616297"/>
+        <p14:creationId xmlns:p14="http://schemas.microsoft.com/office/powerpoint/2010/main" val="1308063593"/>
       </p:ext>
     </p:extLst>
   </p:cSld>
@@ -3354,7 +3354,7 @@
           <p:cNvPr id="2" name="Shape 0">
             <a:extLst xmlns:a="http://schemas.openxmlformats.org/drawingml/2006/main">
               <a:ext uri="{FF2B5EF4-FFF2-40B4-BE49-F238E27FC236}">
-                <a16:creationId xmlns:a16="http://schemas.microsoft.com/office/drawing/2014/main" id="{6A9E9DD8-40C7-4C10-8B5D-29B36CF71FF3}"/>
+                <a16:creationId xmlns:a16="http://schemas.microsoft.com/office/drawing/2014/main" id="{34E0F547-E906-4285-8FC4-9F77BB5DA7DA}"/>
               </a:ext>
             </a:extLst>
           </p:cNvPr>
@@ -3387,7 +3387,7 @@
           <p:cNvPr id="3" name="Text 1">
             <a:extLst xmlns:a="http://schemas.openxmlformats.org/drawingml/2006/main">
               <a:ext uri="{FF2B5EF4-FFF2-40B4-BE49-F238E27FC236}">
-                <a16:creationId xmlns:a16="http://schemas.microsoft.com/office/drawing/2014/main" id="{9C42F899-61E4-4948-A998-1F89F1BFA7EE}"/>
+                <a16:creationId xmlns:a16="http://schemas.microsoft.com/office/drawing/2014/main" id="{4A28F6B2-A4C0-4FF8-A3FD-2DDFF3C5EC74}"/>
               </a:ext>
             </a:extLst>
           </p:cNvPr>
@@ -3434,7 +3434,7 @@
           <p:cNvPr id="4" name="Text 2">
             <a:extLst xmlns:a="http://schemas.openxmlformats.org/drawingml/2006/main">
               <a:ext uri="{FF2B5EF4-FFF2-40B4-BE49-F238E27FC236}">
-                <a16:creationId xmlns:a16="http://schemas.microsoft.com/office/drawing/2014/main" id="{BC1197F0-5126-480F-9A4F-A6C0125D0624}"/>
+                <a16:creationId xmlns:a16="http://schemas.microsoft.com/office/drawing/2014/main" id="{35D601F2-D463-4223-8A1B-7821523B76E9}"/>
               </a:ext>
             </a:extLst>
           </p:cNvPr>
@@ -3481,7 +3481,7 @@
           <p:cNvPr id="5" name="Shape 3">
             <a:extLst xmlns:a="http://schemas.openxmlformats.org/drawingml/2006/main">
               <a:ext uri="{FF2B5EF4-FFF2-40B4-BE49-F238E27FC236}">
-                <a16:creationId xmlns:a16="http://schemas.microsoft.com/office/drawing/2014/main" id="{79DD3514-4C93-42EC-866D-88DC7DC5A80B}"/>
+                <a16:creationId xmlns:a16="http://schemas.microsoft.com/office/drawing/2014/main" id="{AE24FB09-0BA0-4B17-82F3-264151BAC75B}"/>
               </a:ext>
             </a:extLst>
           </p:cNvPr>
@@ -3512,7 +3512,7 @@
           <p:cNvPr id="6" name="Text 4">
             <a:extLst xmlns:a="http://schemas.openxmlformats.org/drawingml/2006/main">
               <a:ext uri="{FF2B5EF4-FFF2-40B4-BE49-F238E27FC236}">
-                <a16:creationId xmlns:a16="http://schemas.microsoft.com/office/drawing/2014/main" id="{7A6A25C9-5709-46B7-A735-0A92190A1D76}"/>
+                <a16:creationId xmlns:a16="http://schemas.microsoft.com/office/drawing/2014/main" id="{BA645970-E166-4B43-8C27-22342955E8CE}"/>
               </a:ext>
             </a:extLst>
           </p:cNvPr>
@@ -3566,7 +3566,7 @@
           <p:cNvPr id="7" name="Text 5">
             <a:extLst xmlns:a="http://schemas.openxmlformats.org/drawingml/2006/main">
               <a:ext uri="{FF2B5EF4-FFF2-40B4-BE49-F238E27FC236}">
-                <a16:creationId xmlns:a16="http://schemas.microsoft.com/office/drawing/2014/main" id="{95459653-C686-4937-8825-A004F4923CA7}"/>
+                <a16:creationId xmlns:a16="http://schemas.microsoft.com/office/drawing/2014/main" id="{AA5C6DF0-3F84-41C5-8463-CEFEF495DA37}"/>
               </a:ext>
             </a:extLst>
           </p:cNvPr>
@@ -3620,7 +3620,7 @@
           <p:cNvPr id="8" name="Text 6">
             <a:extLst xmlns:a="http://schemas.openxmlformats.org/drawingml/2006/main">
               <a:ext uri="{FF2B5EF4-FFF2-40B4-BE49-F238E27FC236}">
-                <a16:creationId xmlns:a16="http://schemas.microsoft.com/office/drawing/2014/main" id="{35A8DE28-292A-45CD-9079-189636AE5774}"/>
+                <a16:creationId xmlns:a16="http://schemas.microsoft.com/office/drawing/2014/main" id="{FE98A641-2D51-4DB4-ABCD-E5B3BFD1FE31}"/>
               </a:ext>
             </a:extLst>
           </p:cNvPr>
@@ -3674,7 +3674,7 @@
           <p:cNvPr id="9" name="Text 7">
             <a:extLst xmlns:a="http://schemas.openxmlformats.org/drawingml/2006/main">
               <a:ext uri="{FF2B5EF4-FFF2-40B4-BE49-F238E27FC236}">
-                <a16:creationId xmlns:a16="http://schemas.microsoft.com/office/drawing/2014/main" id="{0B38C152-9D68-4FF2-BDE8-2B735881494F}"/>
+                <a16:creationId xmlns:a16="http://schemas.microsoft.com/office/drawing/2014/main" id="{53730B15-6FB0-456B-9A4D-7A5D564EBD52}"/>
               </a:ext>
             </a:extLst>
           </p:cNvPr>
@@ -3728,7 +3728,7 @@
           <p:cNvPr id="10" name="Text 8">
             <a:extLst xmlns:a="http://schemas.openxmlformats.org/drawingml/2006/main">
               <a:ext uri="{FF2B5EF4-FFF2-40B4-BE49-F238E27FC236}">
-                <a16:creationId xmlns:a16="http://schemas.microsoft.com/office/drawing/2014/main" id="{158F75A6-D349-41FC-9F0B-FC6337052F47}"/>
+                <a16:creationId xmlns:a16="http://schemas.microsoft.com/office/drawing/2014/main" id="{D15A7C3D-25EC-47E5-A774-FAF92861A1E7}"/>
               </a:ext>
             </a:extLst>
           </p:cNvPr>
@@ -3782,7 +3782,7 @@
           <p:cNvPr id="11" name="Text 9">
             <a:extLst xmlns:a="http://schemas.openxmlformats.org/drawingml/2006/main">
               <a:ext uri="{FF2B5EF4-FFF2-40B4-BE49-F238E27FC236}">
-                <a16:creationId xmlns:a16="http://schemas.microsoft.com/office/drawing/2014/main" id="{4ED8A0DC-3D20-4D97-8D18-CCFD7F7201D5}"/>
+                <a16:creationId xmlns:a16="http://schemas.microsoft.com/office/drawing/2014/main" id="{32411978-DF94-4E92-B082-1D5D85AD0CD5}"/>
               </a:ext>
             </a:extLst>
           </p:cNvPr>
@@ -3836,7 +3836,7 @@
           <p:cNvPr id="12" name="Text 10">
             <a:extLst xmlns:a="http://schemas.openxmlformats.org/drawingml/2006/main">
               <a:ext uri="{FF2B5EF4-FFF2-40B4-BE49-F238E27FC236}">
-                <a16:creationId xmlns:a16="http://schemas.microsoft.com/office/drawing/2014/main" id="{CAF5F467-5CA2-4C3C-8E30-4E520FB95AA3}"/>
+                <a16:creationId xmlns:a16="http://schemas.microsoft.com/office/drawing/2014/main" id="{D910D9A8-86D7-4BAA-AFE0-4765FA10CF17}"/>
               </a:ext>
             </a:extLst>
           </p:cNvPr>
@@ -3890,7 +3890,7 @@
           <p:cNvPr id="13" name="Text 11">
             <a:extLst xmlns:a="http://schemas.openxmlformats.org/drawingml/2006/main">
               <a:ext uri="{FF2B5EF4-FFF2-40B4-BE49-F238E27FC236}">
-                <a16:creationId xmlns:a16="http://schemas.microsoft.com/office/drawing/2014/main" id="{B053B971-63FF-4337-90D0-10408BCFEC51}"/>
+                <a16:creationId xmlns:a16="http://schemas.microsoft.com/office/drawing/2014/main" id="{3FDDCC4E-8491-4CB0-AB3D-DBC858F4EB5C}"/>
               </a:ext>
             </a:extLst>
           </p:cNvPr>
@@ -3944,7 +3944,7 @@
           <p:cNvPr id="14" name="Text 12">
             <a:extLst xmlns:a="http://schemas.openxmlformats.org/drawingml/2006/main">
               <a:ext uri="{FF2B5EF4-FFF2-40B4-BE49-F238E27FC236}">
-                <a16:creationId xmlns:a16="http://schemas.microsoft.com/office/drawing/2014/main" id="{0B5EC9CD-D141-4B72-8171-20571BF66261}"/>
+                <a16:creationId xmlns:a16="http://schemas.microsoft.com/office/drawing/2014/main" id="{EFDEA316-A2A1-4EE1-9B3D-B6377D1AE362}"/>
               </a:ext>
             </a:extLst>
           </p:cNvPr>
@@ -3998,7 +3998,7 @@
           <p:cNvPr id="15" name="Text 13">
             <a:extLst xmlns:a="http://schemas.openxmlformats.org/drawingml/2006/main">
               <a:ext uri="{FF2B5EF4-FFF2-40B4-BE49-F238E27FC236}">
-                <a16:creationId xmlns:a16="http://schemas.microsoft.com/office/drawing/2014/main" id="{FE4018A1-B951-4389-96EF-92D4F79FB807}"/>
+                <a16:creationId xmlns:a16="http://schemas.microsoft.com/office/drawing/2014/main" id="{8BE52F73-E3C9-4C1E-881C-B058683CBAEB}"/>
               </a:ext>
             </a:extLst>
           </p:cNvPr>
@@ -4052,7 +4052,7 @@
           <p:cNvPr id="16" name="Text 14">
             <a:extLst xmlns:a="http://schemas.openxmlformats.org/drawingml/2006/main">
               <a:ext uri="{FF2B5EF4-FFF2-40B4-BE49-F238E27FC236}">
-                <a16:creationId xmlns:a16="http://schemas.microsoft.com/office/drawing/2014/main" id="{3D74C4CE-25BE-4C49-AA05-0175D6873E97}"/>
+                <a16:creationId xmlns:a16="http://schemas.microsoft.com/office/drawing/2014/main" id="{B915AF06-5507-4ADB-AAFB-0C0EE9CD2738}"/>
               </a:ext>
             </a:extLst>
           </p:cNvPr>
@@ -4125,7 +4125,7 @@
     </p:spTree>
     <p:extLst>
       <p:ext uri="{BB962C8B-B14F-4D97-AF65-F5344CB8AC3E}">
-        <p14:creationId xmlns:p14="http://schemas.microsoft.com/office/powerpoint/2010/main" val="82527397"/>
+        <p14:creationId xmlns:p14="http://schemas.microsoft.com/office/powerpoint/2010/main" val="289246789"/>
       </p:ext>
     </p:extLst>
   </p:cSld>
@@ -4156,7 +4156,7 @@
           <p:cNvPr id="2" name="Shape 0">
             <a:extLst xmlns:a="http://schemas.openxmlformats.org/drawingml/2006/main">
               <a:ext uri="{FF2B5EF4-FFF2-40B4-BE49-F238E27FC236}">
-                <a16:creationId xmlns:a16="http://schemas.microsoft.com/office/drawing/2014/main" id="{44E37DCC-7D7D-4C9E-B9A1-B38C0B25DAB6}"/>
+                <a16:creationId xmlns:a16="http://schemas.microsoft.com/office/drawing/2014/main" id="{C6DCFA57-8C0B-4C91-A8E4-BE701EB3CB23}"/>
               </a:ext>
             </a:extLst>
           </p:cNvPr>
@@ -4189,7 +4189,7 @@
           <p:cNvPr id="3" name="Text 1">
             <a:extLst xmlns:a="http://schemas.openxmlformats.org/drawingml/2006/main">
               <a:ext uri="{FF2B5EF4-FFF2-40B4-BE49-F238E27FC236}">
-                <a16:creationId xmlns:a16="http://schemas.microsoft.com/office/drawing/2014/main" id="{DE4A09AE-192F-499B-9AAE-9C22F32D75BD}"/>
+                <a16:creationId xmlns:a16="http://schemas.microsoft.com/office/drawing/2014/main" id="{35A84816-018E-4AAF-8882-DBDD0BC93BDD}"/>
               </a:ext>
             </a:extLst>
           </p:cNvPr>
@@ -4236,7 +4236,7 @@
           <p:cNvPr id="4" name="Text 2">
             <a:extLst xmlns:a="http://schemas.openxmlformats.org/drawingml/2006/main">
               <a:ext uri="{FF2B5EF4-FFF2-40B4-BE49-F238E27FC236}">
-                <a16:creationId xmlns:a16="http://schemas.microsoft.com/office/drawing/2014/main" id="{EEF9108D-7E7F-4C44-88C8-0847F626654C}"/>
+                <a16:creationId xmlns:a16="http://schemas.microsoft.com/office/drawing/2014/main" id="{214B4740-90B2-4269-A78D-9C8718CB25E4}"/>
               </a:ext>
             </a:extLst>
           </p:cNvPr>
@@ -4283,7 +4283,7 @@
           <p:cNvPr id="5" name="Shape 3">
             <a:extLst xmlns:a="http://schemas.openxmlformats.org/drawingml/2006/main">
               <a:ext uri="{FF2B5EF4-FFF2-40B4-BE49-F238E27FC236}">
-                <a16:creationId xmlns:a16="http://schemas.microsoft.com/office/drawing/2014/main" id="{8433C2A4-B309-4374-8A84-1C8AC2F8460B}"/>
+                <a16:creationId xmlns:a16="http://schemas.microsoft.com/office/drawing/2014/main" id="{C231FB54-3203-4A3A-B0B6-707063304A37}"/>
               </a:ext>
             </a:extLst>
           </p:cNvPr>
@@ -4314,7 +4314,7 @@
           <p:cNvPr id="6" name="Text 4">
             <a:extLst xmlns:a="http://schemas.openxmlformats.org/drawingml/2006/main">
               <a:ext uri="{FF2B5EF4-FFF2-40B4-BE49-F238E27FC236}">
-                <a16:creationId xmlns:a16="http://schemas.microsoft.com/office/drawing/2014/main" id="{5D1271BC-B7B6-4389-8E28-A098F92E2190}"/>
+                <a16:creationId xmlns:a16="http://schemas.microsoft.com/office/drawing/2014/main" id="{03A8800A-0B89-46BF-8725-9C2AB5BD57CE}"/>
               </a:ext>
             </a:extLst>
           </p:cNvPr>
@@ -4453,7 +4453,7 @@
           <p:cNvPr id="7" name="Text 5">
             <a:extLst xmlns:a="http://schemas.openxmlformats.org/drawingml/2006/main">
               <a:ext uri="{FF2B5EF4-FFF2-40B4-BE49-F238E27FC236}">
-                <a16:creationId xmlns:a16="http://schemas.microsoft.com/office/drawing/2014/main" id="{84681E52-7EFB-49BA-BF9B-482E2667DCD1}"/>
+                <a16:creationId xmlns:a16="http://schemas.microsoft.com/office/drawing/2014/main" id="{F4B96212-1302-4722-A20C-B5CB14FB707E}"/>
               </a:ext>
             </a:extLst>
           </p:cNvPr>
@@ -4690,7 +4690,7 @@
     </p:spTree>
     <p:extLst>
       <p:ext uri="{BB962C8B-B14F-4D97-AF65-F5344CB8AC3E}">
-        <p14:creationId xmlns:p14="http://schemas.microsoft.com/office/powerpoint/2010/main" val="1270667223"/>
+        <p14:creationId xmlns:p14="http://schemas.microsoft.com/office/powerpoint/2010/main" val="1928670811"/>
       </p:ext>
     </p:extLst>
   </p:cSld>
@@ -4721,7 +4721,7 @@
           <p:cNvPr id="2" name="Shape 0">
             <a:extLst xmlns:a="http://schemas.openxmlformats.org/drawingml/2006/main">
               <a:ext uri="{FF2B5EF4-FFF2-40B4-BE49-F238E27FC236}">
-                <a16:creationId xmlns:a16="http://schemas.microsoft.com/office/drawing/2014/main" id="{82C8F52F-5DFA-40F8-9731-EBFDFF973C93}"/>
+                <a16:creationId xmlns:a16="http://schemas.microsoft.com/office/drawing/2014/main" id="{DD7751E5-8E9C-4D3B-BE68-61A6EBB59E85}"/>
               </a:ext>
             </a:extLst>
           </p:cNvPr>
@@ -4754,7 +4754,7 @@
           <p:cNvPr id="3" name="Text 1">
             <a:extLst xmlns:a="http://schemas.openxmlformats.org/drawingml/2006/main">
               <a:ext uri="{FF2B5EF4-FFF2-40B4-BE49-F238E27FC236}">
-                <a16:creationId xmlns:a16="http://schemas.microsoft.com/office/drawing/2014/main" id="{8E71983F-8EB1-4FAA-824F-3B7E350B3A62}"/>
+                <a16:creationId xmlns:a16="http://schemas.microsoft.com/office/drawing/2014/main" id="{AD9E1951-C707-4B8A-9586-FD99BA5F4D74}"/>
               </a:ext>
             </a:extLst>
           </p:cNvPr>
@@ -4801,7 +4801,7 @@
           <p:cNvPr id="4" name="Text 2">
             <a:extLst xmlns:a="http://schemas.openxmlformats.org/drawingml/2006/main">
               <a:ext uri="{FF2B5EF4-FFF2-40B4-BE49-F238E27FC236}">
-                <a16:creationId xmlns:a16="http://schemas.microsoft.com/office/drawing/2014/main" id="{44D419F7-E9C7-49BD-8C81-915F15D59A3D}"/>
+                <a16:creationId xmlns:a16="http://schemas.microsoft.com/office/drawing/2014/main" id="{00946CC2-A844-4E81-A26E-6A0B1046A8CB}"/>
               </a:ext>
             </a:extLst>
           </p:cNvPr>
@@ -4848,7 +4848,7 @@
           <p:cNvPr id="5" name="Shape 3">
             <a:extLst xmlns:a="http://schemas.openxmlformats.org/drawingml/2006/main">
               <a:ext uri="{FF2B5EF4-FFF2-40B4-BE49-F238E27FC236}">
-                <a16:creationId xmlns:a16="http://schemas.microsoft.com/office/drawing/2014/main" id="{27EC363A-F705-431A-B62B-26C1049A7521}"/>
+                <a16:creationId xmlns:a16="http://schemas.microsoft.com/office/drawing/2014/main" id="{35C548B0-7E16-46C3-9D60-99D7704AFB04}"/>
               </a:ext>
             </a:extLst>
           </p:cNvPr>
@@ -4879,7 +4879,7 @@
           <p:cNvPr id="6" name="Text 4">
             <a:extLst xmlns:a="http://schemas.openxmlformats.org/drawingml/2006/main">
               <a:ext uri="{FF2B5EF4-FFF2-40B4-BE49-F238E27FC236}">
-                <a16:creationId xmlns:a16="http://schemas.microsoft.com/office/drawing/2014/main" id="{0C2CB033-F0C9-4FC0-A5F7-A6929AB2C797}"/>
+                <a16:creationId xmlns:a16="http://schemas.microsoft.com/office/drawing/2014/main" id="{F8EEBCEF-16BA-46F3-8BE1-8FA4F5CE9013}"/>
               </a:ext>
             </a:extLst>
           </p:cNvPr>
@@ -5018,7 +5018,7 @@
           <p:cNvPr id="7" name="Text 5">
             <a:extLst xmlns:a="http://schemas.openxmlformats.org/drawingml/2006/main">
               <a:ext uri="{FF2B5EF4-FFF2-40B4-BE49-F238E27FC236}">
-                <a16:creationId xmlns:a16="http://schemas.microsoft.com/office/drawing/2014/main" id="{5727FA56-7ABA-4D55-9062-9367B889D47B}"/>
+                <a16:creationId xmlns:a16="http://schemas.microsoft.com/office/drawing/2014/main" id="{064CD44D-6BD6-4929-B164-7C26BBF49DEF}"/>
               </a:ext>
             </a:extLst>
           </p:cNvPr>
@@ -5170,7 +5170,7 @@
     </p:spTree>
     <p:extLst>
       <p:ext uri="{BB962C8B-B14F-4D97-AF65-F5344CB8AC3E}">
-        <p14:creationId xmlns:p14="http://schemas.microsoft.com/office/powerpoint/2010/main" val="1847528257"/>
+        <p14:creationId xmlns:p14="http://schemas.microsoft.com/office/powerpoint/2010/main" val="2034545716"/>
       </p:ext>
     </p:extLst>
   </p:cSld>
@@ -5201,7 +5201,7 @@
           <p:cNvPr id="1" name="">
             <a:extLst xmlns:a="http://schemas.openxmlformats.org/drawingml/2006/main">
               <a:ext uri="{FF2B5EF4-FFF2-40B4-BE49-F238E27FC236}">
-                <a16:creationId xmlns:a16="http://schemas.microsoft.com/office/drawing/2014/main" id="{90228603-DDC4-44FE-B9B5-5A6279B65EA8}"/>
+                <a16:creationId xmlns:a16="http://schemas.microsoft.com/office/drawing/2014/main" id="{A31D260D-3ED6-4497-9523-2008BC92E1D2}"/>
               </a:ext>
             </a:extLst>
           </p:cNvPr>
@@ -5231,7 +5231,7 @@
           <p:cNvPr id="2" name="">
             <a:extLst xmlns:a="http://schemas.openxmlformats.org/drawingml/2006/main">
               <a:ext uri="{FF2B5EF4-FFF2-40B4-BE49-F238E27FC236}">
-                <a16:creationId xmlns:a16="http://schemas.microsoft.com/office/drawing/2014/main" id="{4D9FE2F2-E495-468D-9D45-FBBF9FA9537B}"/>
+                <a16:creationId xmlns:a16="http://schemas.microsoft.com/office/drawing/2014/main" id="{FC97F84A-22F7-4E57-9238-696380D7A021}"/>
               </a:ext>
             </a:extLst>
           </p:cNvPr>
@@ -5277,7 +5277,7 @@
           <p:cNvPr id="3" name="">
             <a:extLst xmlns:a="http://schemas.openxmlformats.org/drawingml/2006/main">
               <a:ext uri="{FF2B5EF4-FFF2-40B4-BE49-F238E27FC236}">
-                <a16:creationId xmlns:a16="http://schemas.microsoft.com/office/drawing/2014/main" id="{44C025EB-66E2-4EFD-8248-AC3447ADAEE3}"/>
+                <a16:creationId xmlns:a16="http://schemas.microsoft.com/office/drawing/2014/main" id="{2A53215E-F87C-4169-AC16-A9C85094CE30}"/>
               </a:ext>
             </a:extLst>
           </p:cNvPr>
@@ -5323,7 +5323,7 @@
           <p:cNvPr id="4" name="">
             <a:extLst xmlns:a="http://schemas.openxmlformats.org/drawingml/2006/main">
               <a:ext uri="{FF2B5EF4-FFF2-40B4-BE49-F238E27FC236}">
-                <a16:creationId xmlns:a16="http://schemas.microsoft.com/office/drawing/2014/main" id="{6A1EDB1E-A661-424C-990A-E5EE08B9111C}"/>
+                <a16:creationId xmlns:a16="http://schemas.microsoft.com/office/drawing/2014/main" id="{6DDCF55F-41AF-44E5-B72E-CB2D3E186793}"/>
               </a:ext>
             </a:extLst>
           </p:cNvPr>
@@ -5359,7 +5359,7 @@
                   <a:srgbClr val="97A0AA"/>
                 </a:solidFill>
               </a:rPr>
-              <a:t>A compact dbt + DuckDB benchmark repo that makes prompt quality visibly matter.</a:t>
+              <a:t>A compact dbt + DuckDB benchmark repo designed for a two-session prompt-efficiency comparison.</a:t>
             </a:r>
           </a:p>
         </p:txBody>
@@ -5369,7 +5369,7 @@
           <p:cNvPr id="5" name="">
             <a:extLst xmlns:a="http://schemas.openxmlformats.org/drawingml/2006/main">
               <a:ext uri="{FF2B5EF4-FFF2-40B4-BE49-F238E27FC236}">
-                <a16:creationId xmlns:a16="http://schemas.microsoft.com/office/drawing/2014/main" id="{52830EC2-B2DA-45DB-90D1-44D794C1CAF7}"/>
+                <a16:creationId xmlns:a16="http://schemas.microsoft.com/office/drawing/2014/main" id="{640D95C6-C927-4E8B-9D8B-F788E2292DCA}"/>
               </a:ext>
             </a:extLst>
           </p:cNvPr>
@@ -5404,7 +5404,7 @@
           <p:cNvPr id="6" name="">
             <a:extLst xmlns:a="http://schemas.openxmlformats.org/drawingml/2006/main">
               <a:ext uri="{FF2B5EF4-FFF2-40B4-BE49-F238E27FC236}">
-                <a16:creationId xmlns:a16="http://schemas.microsoft.com/office/drawing/2014/main" id="{71681246-CD8E-4EAB-9EA1-D40824BBA919}"/>
+                <a16:creationId xmlns:a16="http://schemas.microsoft.com/office/drawing/2014/main" id="{8D7719B0-12D3-42AA-BA4D-0C05C069C0AD}"/>
               </a:ext>
             </a:extLst>
           </p:cNvPr>
@@ -5450,7 +5450,7 @@
           <p:cNvPr id="7" name="">
             <a:extLst xmlns:a="http://schemas.openxmlformats.org/drawingml/2006/main">
               <a:ext uri="{FF2B5EF4-FFF2-40B4-BE49-F238E27FC236}">
-                <a16:creationId xmlns:a16="http://schemas.microsoft.com/office/drawing/2014/main" id="{1F871D18-98AF-4164-9299-A85B2E7A7A1A}"/>
+                <a16:creationId xmlns:a16="http://schemas.microsoft.com/office/drawing/2014/main" id="{28A558BF-2386-4213-91EF-165F5E078B69}"/>
               </a:ext>
             </a:extLst>
           </p:cNvPr>
@@ -5496,7 +5496,7 @@
           <p:cNvPr id="8" name="">
             <a:extLst xmlns:a="http://schemas.openxmlformats.org/drawingml/2006/main">
               <a:ext uri="{FF2B5EF4-FFF2-40B4-BE49-F238E27FC236}">
-                <a16:creationId xmlns:a16="http://schemas.microsoft.com/office/drawing/2014/main" id="{A20762A0-7C24-41FF-B735-86EF53404B8F}"/>
+                <a16:creationId xmlns:a16="http://schemas.microsoft.com/office/drawing/2014/main" id="{E1553297-102D-4DB0-B7AF-DE3DA9C2CE80}"/>
               </a:ext>
             </a:extLst>
           </p:cNvPr>
@@ -5542,7 +5542,7 @@
           <p:cNvPr id="9" name="">
             <a:extLst xmlns:a="http://schemas.openxmlformats.org/drawingml/2006/main">
               <a:ext uri="{FF2B5EF4-FFF2-40B4-BE49-F238E27FC236}">
-                <a16:creationId xmlns:a16="http://schemas.microsoft.com/office/drawing/2014/main" id="{1EACE45F-35C2-4A5F-9864-449DD8D25C5A}"/>
+                <a16:creationId xmlns:a16="http://schemas.microsoft.com/office/drawing/2014/main" id="{8F2F3E2E-EBE9-46D6-AF43-4097946FC02B}"/>
               </a:ext>
             </a:extLst>
           </p:cNvPr>
@@ -5588,7 +5588,7 @@
           <p:cNvPr id="10" name="">
             <a:extLst xmlns:a="http://schemas.openxmlformats.org/drawingml/2006/main">
               <a:ext uri="{FF2B5EF4-FFF2-40B4-BE49-F238E27FC236}">
-                <a16:creationId xmlns:a16="http://schemas.microsoft.com/office/drawing/2014/main" id="{958D095C-3C92-4400-BAEB-83FC8CC5A355}"/>
+                <a16:creationId xmlns:a16="http://schemas.microsoft.com/office/drawing/2014/main" id="{E59C254C-B1CA-44AE-A015-486954532AD5}"/>
               </a:ext>
             </a:extLst>
           </p:cNvPr>
@@ -5634,7 +5634,7 @@
           <p:cNvPr id="11" name="">
             <a:extLst xmlns:a="http://schemas.openxmlformats.org/drawingml/2006/main">
               <a:ext uri="{FF2B5EF4-FFF2-40B4-BE49-F238E27FC236}">
-                <a16:creationId xmlns:a16="http://schemas.microsoft.com/office/drawing/2014/main" id="{707231E8-EA02-48BF-B227-7836F9A0BFA3}"/>
+                <a16:creationId xmlns:a16="http://schemas.microsoft.com/office/drawing/2014/main" id="{7F984685-3FAE-4358-BE69-DA7AA135E28D}"/>
               </a:ext>
             </a:extLst>
           </p:cNvPr>
@@ -5669,7 +5669,7 @@
           <p:cNvPr id="12" name="">
             <a:extLst xmlns:a="http://schemas.openxmlformats.org/drawingml/2006/main">
               <a:ext uri="{FF2B5EF4-FFF2-40B4-BE49-F238E27FC236}">
-                <a16:creationId xmlns:a16="http://schemas.microsoft.com/office/drawing/2014/main" id="{6D4D7BF0-08C3-4BC9-AB32-66EE61059F06}"/>
+                <a16:creationId xmlns:a16="http://schemas.microsoft.com/office/drawing/2014/main" id="{A425E598-1948-4615-B66A-2563DE0AE2AF}"/>
               </a:ext>
             </a:extLst>
           </p:cNvPr>
@@ -5715,7 +5715,7 @@
           <p:cNvPr id="13" name="">
             <a:extLst xmlns:a="http://schemas.openxmlformats.org/drawingml/2006/main">
               <a:ext uri="{FF2B5EF4-FFF2-40B4-BE49-F238E27FC236}">
-                <a16:creationId xmlns:a16="http://schemas.microsoft.com/office/drawing/2014/main" id="{4BAB7BB2-126D-4EF3-A6CB-A27767D910E6}"/>
+                <a16:creationId xmlns:a16="http://schemas.microsoft.com/office/drawing/2014/main" id="{15C5BF3C-5B59-48E9-99B9-75B5143CE3AA}"/>
               </a:ext>
             </a:extLst>
           </p:cNvPr>
@@ -5764,7 +5764,7 @@
           <p:cNvPr id="14" name="">
             <a:extLst xmlns:a="http://schemas.openxmlformats.org/drawingml/2006/main">
               <a:ext uri="{FF2B5EF4-FFF2-40B4-BE49-F238E27FC236}">
-                <a16:creationId xmlns:a16="http://schemas.microsoft.com/office/drawing/2014/main" id="{6A46D754-3A5B-4380-B84E-DD92B76D861D}"/>
+                <a16:creationId xmlns:a16="http://schemas.microsoft.com/office/drawing/2014/main" id="{C3CFDACE-C491-444C-BB7A-F426C33114EC}"/>
               </a:ext>
             </a:extLst>
           </p:cNvPr>
@@ -5800,7 +5800,7 @@
                   <a:srgbClr val="F5F6F7"/>
                 </a:solidFill>
               </a:rPr>
-              <a:t>Discovery</a:t>
+              <a:t>Session 1</a:t>
             </a:r>
           </a:p>
         </p:txBody>
@@ -5810,7 +5810,7 @@
           <p:cNvPr id="15" name="">
             <a:extLst xmlns:a="http://schemas.openxmlformats.org/drawingml/2006/main">
               <a:ext uri="{FF2B5EF4-FFF2-40B4-BE49-F238E27FC236}">
-                <a16:creationId xmlns:a16="http://schemas.microsoft.com/office/drawing/2014/main" id="{1455292B-6A52-4C3B-B2A8-82D3F4F65BD1}"/>
+                <a16:creationId xmlns:a16="http://schemas.microsoft.com/office/drawing/2014/main" id="{FCCBE47B-7648-4A11-BE86-F30A862212A4}"/>
               </a:ext>
             </a:extLst>
           </p:cNvPr>
@@ -5846,7 +5846,7 @@
                   <a:srgbClr val="D6D8DC"/>
                 </a:solidFill>
               </a:rPr>
-              <a:t>Create docs/repo_map.md without widening scope.</a:t>
+              <a:t>Discovery + impact analysis create reusable repo context.</a:t>
             </a:r>
           </a:p>
         </p:txBody>
@@ -5856,7 +5856,7 @@
           <p:cNvPr id="16" name="">
             <a:extLst xmlns:a="http://schemas.openxmlformats.org/drawingml/2006/main">
               <a:ext uri="{FF2B5EF4-FFF2-40B4-BE49-F238E27FC236}">
-                <a16:creationId xmlns:a16="http://schemas.microsoft.com/office/drawing/2014/main" id="{AC17427D-44AE-4913-BCFC-16D9E299F610}"/>
+                <a16:creationId xmlns:a16="http://schemas.microsoft.com/office/drawing/2014/main" id="{A41BCDA9-F5CE-47AA-9D39-B470E12981F1}"/>
               </a:ext>
             </a:extLst>
           </p:cNvPr>
@@ -5905,7 +5905,7 @@
           <p:cNvPr id="17" name="">
             <a:extLst xmlns:a="http://schemas.openxmlformats.org/drawingml/2006/main">
               <a:ext uri="{FF2B5EF4-FFF2-40B4-BE49-F238E27FC236}">
-                <a16:creationId xmlns:a16="http://schemas.microsoft.com/office/drawing/2014/main" id="{0EB05EAF-A066-4B0B-BDD6-898C28F45622}"/>
+                <a16:creationId xmlns:a16="http://schemas.microsoft.com/office/drawing/2014/main" id="{2FA58050-8C6E-49CD-BC6F-829E7362CD2A}"/>
               </a:ext>
             </a:extLst>
           </p:cNvPr>
@@ -5941,7 +5941,7 @@
                   <a:srgbClr val="F5F6F7"/>
                 </a:solidFill>
               </a:rPr>
-              <a:t>Impact analysis</a:t>
+              <a:t>Reset chat</a:t>
             </a:r>
           </a:p>
         </p:txBody>
@@ -5951,7 +5951,7 @@
           <p:cNvPr id="18" name="">
             <a:extLst xmlns:a="http://schemas.openxmlformats.org/drawingml/2006/main">
               <a:ext uri="{FF2B5EF4-FFF2-40B4-BE49-F238E27FC236}">
-                <a16:creationId xmlns:a16="http://schemas.microsoft.com/office/drawing/2014/main" id="{0DBDA343-14FC-448A-A855-CEC9D2BED0F7}"/>
+                <a16:creationId xmlns:a16="http://schemas.microsoft.com/office/drawing/2014/main" id="{84D599B3-2549-489A-8A05-8034D46DCDA0}"/>
               </a:ext>
             </a:extLst>
           </p:cNvPr>
@@ -5987,7 +5987,7 @@
                   <a:srgbClr val="D6D8DC"/>
                 </a:solidFill>
               </a:rPr>
-              <a:t>Assess USD normalization using one-layer lineage expansion.</a:t>
+              <a:t>Start a fresh agent session but keep the repo artifacts.</a:t>
             </a:r>
           </a:p>
         </p:txBody>
@@ -5997,7 +5997,7 @@
           <p:cNvPr id="19" name="">
             <a:extLst xmlns:a="http://schemas.openxmlformats.org/drawingml/2006/main">
               <a:ext uri="{FF2B5EF4-FFF2-40B4-BE49-F238E27FC236}">
-                <a16:creationId xmlns:a16="http://schemas.microsoft.com/office/drawing/2014/main" id="{A77FC688-D657-447C-9459-C4DFD42A61E3}"/>
+                <a16:creationId xmlns:a16="http://schemas.microsoft.com/office/drawing/2014/main" id="{6D573D2E-72E5-49D6-A7BD-9CB3151406E4}"/>
               </a:ext>
             </a:extLst>
           </p:cNvPr>
@@ -6046,7 +6046,7 @@
           <p:cNvPr id="20" name="">
             <a:extLst xmlns:a="http://schemas.openxmlformats.org/drawingml/2006/main">
               <a:ext uri="{FF2B5EF4-FFF2-40B4-BE49-F238E27FC236}">
-                <a16:creationId xmlns:a16="http://schemas.microsoft.com/office/drawing/2014/main" id="{51B71FB3-DEBE-41F6-8220-C0DE65FFDF35}"/>
+                <a16:creationId xmlns:a16="http://schemas.microsoft.com/office/drawing/2014/main" id="{D55FE8CF-6F25-4E4E-A2EF-A5AC06A7406F}"/>
               </a:ext>
             </a:extLst>
           </p:cNvPr>
@@ -6082,7 +6082,7 @@
                   <a:srgbClr val="F5F6F7"/>
                 </a:solidFill>
               </a:rPr>
-              <a:t>Implementation</a:t>
+              <a:t>Session 2</a:t>
             </a:r>
           </a:p>
         </p:txBody>
@@ -6092,7 +6092,7 @@
           <p:cNvPr id="21" name="">
             <a:extLst xmlns:a="http://schemas.openxmlformats.org/drawingml/2006/main">
               <a:ext uri="{FF2B5EF4-FFF2-40B4-BE49-F238E27FC236}">
-                <a16:creationId xmlns:a16="http://schemas.microsoft.com/office/drawing/2014/main" id="{B9E50E3F-A327-4529-9EB8-F11EFBD3B7FE}"/>
+                <a16:creationId xmlns:a16="http://schemas.microsoft.com/office/drawing/2014/main" id="{19AFFA2D-7650-4F8B-9E97-C91E2AAA7FAA}"/>
               </a:ext>
             </a:extLst>
           </p:cNvPr>
@@ -6128,7 +6128,7 @@
                   <a:srgbClr val="D6D8DC"/>
                 </a:solidFill>
               </a:rPr>
-              <a:t>Add USD metrics and concentration buckets, then validate.</a:t>
+              <a:t>Implementation reuses saved artifacts instead of rediscovery.</a:t>
             </a:r>
           </a:p>
         </p:txBody>
@@ -6136,7 +6136,7 @@
     </p:spTree>
     <p:extLst>
       <p:ext uri="{BB962C8B-B14F-4D97-AF65-F5344CB8AC3E}">
-        <p14:creationId xmlns:p14="http://schemas.microsoft.com/office/powerpoint/2010/main" val="1008372373"/>
+        <p14:creationId xmlns:p14="http://schemas.microsoft.com/office/powerpoint/2010/main" val="1241349362"/>
       </p:ext>
     </p:extLst>
   </p:cSld>
@@ -6167,7 +6167,7 @@
           <p:cNvPr id="1" name="">
             <a:extLst xmlns:a="http://schemas.openxmlformats.org/drawingml/2006/main">
               <a:ext uri="{FF2B5EF4-FFF2-40B4-BE49-F238E27FC236}">
-                <a16:creationId xmlns:a16="http://schemas.microsoft.com/office/drawing/2014/main" id="{6B821A63-4E65-47A0-A0BC-9F8B4AE7DF45}"/>
+                <a16:creationId xmlns:a16="http://schemas.microsoft.com/office/drawing/2014/main" id="{E7AC70A1-7B81-43A1-8061-CF85CD5AB0CF}"/>
               </a:ext>
             </a:extLst>
           </p:cNvPr>
@@ -6197,7 +6197,7 @@
           <p:cNvPr id="2" name="">
             <a:extLst xmlns:a="http://schemas.openxmlformats.org/drawingml/2006/main">
               <a:ext uri="{FF2B5EF4-FFF2-40B4-BE49-F238E27FC236}">
-                <a16:creationId xmlns:a16="http://schemas.microsoft.com/office/drawing/2014/main" id="{4AF9126C-9ABF-45F8-9224-B1A5460A7DFC}"/>
+                <a16:creationId xmlns:a16="http://schemas.microsoft.com/office/drawing/2014/main" id="{E05EC81D-8C52-4A1F-9810-BC1E26D93A3C}"/>
               </a:ext>
             </a:extLst>
           </p:cNvPr>
@@ -6243,7 +6243,7 @@
           <p:cNvPr id="3" name="">
             <a:extLst xmlns:a="http://schemas.openxmlformats.org/drawingml/2006/main">
               <a:ext uri="{FF2B5EF4-FFF2-40B4-BE49-F238E27FC236}">
-                <a16:creationId xmlns:a16="http://schemas.microsoft.com/office/drawing/2014/main" id="{2F17A853-4865-4D11-BFDD-B563C3314D66}"/>
+                <a16:creationId xmlns:a16="http://schemas.microsoft.com/office/drawing/2014/main" id="{17BD00EA-2466-4E45-823B-BAEDFDB27B9F}"/>
               </a:ext>
             </a:extLst>
           </p:cNvPr>
@@ -6289,7 +6289,7 @@
           <p:cNvPr id="4" name="">
             <a:extLst xmlns:a="http://schemas.openxmlformats.org/drawingml/2006/main">
               <a:ext uri="{FF2B5EF4-FFF2-40B4-BE49-F238E27FC236}">
-                <a16:creationId xmlns:a16="http://schemas.microsoft.com/office/drawing/2014/main" id="{6F172AFA-AF97-4EE6-A8BC-5E88A5C4BA32}"/>
+                <a16:creationId xmlns:a16="http://schemas.microsoft.com/office/drawing/2014/main" id="{13B4CEE0-9788-4704-AD4B-91B32638BFB6}"/>
               </a:ext>
             </a:extLst>
           </p:cNvPr>
@@ -6325,7 +6325,7 @@
                   <a:srgbClr val="97A0AA"/>
                 </a:solidFill>
               </a:rPr>
-              <a:t>Define efficiency before the demo starts so the audience knows what to watch.</a:t>
+              <a:t>Define efficiency across two sessions so the audience knows what reuse should look like.</a:t>
             </a:r>
           </a:p>
         </p:txBody>
@@ -6335,7 +6335,7 @@
           <p:cNvPr id="5" name="">
             <a:extLst xmlns:a="http://schemas.openxmlformats.org/drawingml/2006/main">
               <a:ext uri="{FF2B5EF4-FFF2-40B4-BE49-F238E27FC236}">
-                <a16:creationId xmlns:a16="http://schemas.microsoft.com/office/drawing/2014/main" id="{0A16C11D-A245-4DE6-B8DC-3665FC35766D}"/>
+                <a16:creationId xmlns:a16="http://schemas.microsoft.com/office/drawing/2014/main" id="{E77EFEC9-F665-486D-B67E-25411159E5C8}"/>
               </a:ext>
             </a:extLst>
           </p:cNvPr>
@@ -6370,7 +6370,7 @@
           <p:cNvPr id="6" name="">
             <a:extLst xmlns:a="http://schemas.openxmlformats.org/drawingml/2006/main">
               <a:ext uri="{FF2B5EF4-FFF2-40B4-BE49-F238E27FC236}">
-                <a16:creationId xmlns:a16="http://schemas.microsoft.com/office/drawing/2014/main" id="{A70B08C6-FE21-4FF4-B857-EBC62E55F8DD}"/>
+                <a16:creationId xmlns:a16="http://schemas.microsoft.com/office/drawing/2014/main" id="{BE9AA7F1-1ADE-456D-BF2D-6EE3B15A826C}"/>
               </a:ext>
             </a:extLst>
           </p:cNvPr>
@@ -6416,7 +6416,7 @@
           <p:cNvPr id="7" name="">
             <a:extLst xmlns:a="http://schemas.openxmlformats.org/drawingml/2006/main">
               <a:ext uri="{FF2B5EF4-FFF2-40B4-BE49-F238E27FC236}">
-                <a16:creationId xmlns:a16="http://schemas.microsoft.com/office/drawing/2014/main" id="{F74EDB56-CEED-4B02-9189-BDEDEFDFEF34}"/>
+                <a16:creationId xmlns:a16="http://schemas.microsoft.com/office/drawing/2014/main" id="{016C996F-E21E-4FDE-B663-BD2C440A20EB}"/>
               </a:ext>
             </a:extLst>
           </p:cNvPr>
@@ -6451,7 +6451,7 @@
           <p:cNvPr id="8" name="">
             <a:extLst xmlns:a="http://schemas.openxmlformats.org/drawingml/2006/main">
               <a:ext uri="{FF2B5EF4-FFF2-40B4-BE49-F238E27FC236}">
-                <a16:creationId xmlns:a16="http://schemas.microsoft.com/office/drawing/2014/main" id="{9C24A52C-188F-4188-B2E1-D381E229AE0B}"/>
+                <a16:creationId xmlns:a16="http://schemas.microsoft.com/office/drawing/2014/main" id="{8ABBAEB7-5C4C-4548-8901-C805E7AC650C}"/>
               </a:ext>
             </a:extLst>
           </p:cNvPr>
@@ -6497,7 +6497,7 @@
           <p:cNvPr id="9" name="">
             <a:extLst xmlns:a="http://schemas.openxmlformats.org/drawingml/2006/main">
               <a:ext uri="{FF2B5EF4-FFF2-40B4-BE49-F238E27FC236}">
-                <a16:creationId xmlns:a16="http://schemas.microsoft.com/office/drawing/2014/main" id="{80A7AB83-5FD9-4F5A-9039-1754D7D6CFD6}"/>
+                <a16:creationId xmlns:a16="http://schemas.microsoft.com/office/drawing/2014/main" id="{6A58FD6D-0E22-461C-9DB3-E9DA36E565F5}"/>
               </a:ext>
             </a:extLst>
           </p:cNvPr>
@@ -6532,7 +6532,7 @@
           <p:cNvPr id="10" name="">
             <a:extLst xmlns:a="http://schemas.openxmlformats.org/drawingml/2006/main">
               <a:ext uri="{FF2B5EF4-FFF2-40B4-BE49-F238E27FC236}">
-                <a16:creationId xmlns:a16="http://schemas.microsoft.com/office/drawing/2014/main" id="{2AA3502F-6EEB-4793-84A5-DB770D4E2D1F}"/>
+                <a16:creationId xmlns:a16="http://schemas.microsoft.com/office/drawing/2014/main" id="{133E81A3-E095-49AA-BB05-130C84CAD6F2}"/>
               </a:ext>
             </a:extLst>
           </p:cNvPr>
@@ -6578,7 +6578,7 @@
           <p:cNvPr id="11" name="">
             <a:extLst xmlns:a="http://schemas.openxmlformats.org/drawingml/2006/main">
               <a:ext uri="{FF2B5EF4-FFF2-40B4-BE49-F238E27FC236}">
-                <a16:creationId xmlns:a16="http://schemas.microsoft.com/office/drawing/2014/main" id="{A33B1866-E854-4548-AEBC-47772E4B3AAC}"/>
+                <a16:creationId xmlns:a16="http://schemas.microsoft.com/office/drawing/2014/main" id="{9B83B50E-55C6-48CE-96D7-9B3BF92FBBC4}"/>
               </a:ext>
             </a:extLst>
           </p:cNvPr>
@@ -6613,7 +6613,7 @@
           <p:cNvPr id="12" name="">
             <a:extLst xmlns:a="http://schemas.openxmlformats.org/drawingml/2006/main">
               <a:ext uri="{FF2B5EF4-FFF2-40B4-BE49-F238E27FC236}">
-                <a16:creationId xmlns:a16="http://schemas.microsoft.com/office/drawing/2014/main" id="{82FAD769-ED68-49A3-8FE2-A1B5D2495548}"/>
+                <a16:creationId xmlns:a16="http://schemas.microsoft.com/office/drawing/2014/main" id="{5BB7D054-9B1D-4CA8-93AA-455D6195122C}"/>
               </a:ext>
             </a:extLst>
           </p:cNvPr>
@@ -6648,7 +6648,7 @@
           <p:cNvPr id="13" name="">
             <a:extLst xmlns:a="http://schemas.openxmlformats.org/drawingml/2006/main">
               <a:ext uri="{FF2B5EF4-FFF2-40B4-BE49-F238E27FC236}">
-                <a16:creationId xmlns:a16="http://schemas.microsoft.com/office/drawing/2014/main" id="{E97C586C-785D-49BA-B43C-64D8D9DD4C40}"/>
+                <a16:creationId xmlns:a16="http://schemas.microsoft.com/office/drawing/2014/main" id="{6E25A111-E462-4A0F-9574-3FD6D0C6F4F3}"/>
               </a:ext>
             </a:extLst>
           </p:cNvPr>
@@ -6683,7 +6683,7 @@
           <p:cNvPr id="14" name="">
             <a:extLst xmlns:a="http://schemas.openxmlformats.org/drawingml/2006/main">
               <a:ext uri="{FF2B5EF4-FFF2-40B4-BE49-F238E27FC236}">
-                <a16:creationId xmlns:a16="http://schemas.microsoft.com/office/drawing/2014/main" id="{DA4F0BF2-356C-4321-BA46-ABD475219BE1}"/>
+                <a16:creationId xmlns:a16="http://schemas.microsoft.com/office/drawing/2014/main" id="{C9E487B1-5913-4873-BD9F-9E08325EC416}"/>
               </a:ext>
             </a:extLst>
           </p:cNvPr>
@@ -6719,7 +6719,7 @@
                   <a:srgbClr val="F5F6F7"/>
                 </a:solidFill>
               </a:rPr>
-              <a:t>Files inspected</a:t>
+              <a:t>Session 1 churn</a:t>
             </a:r>
           </a:p>
         </p:txBody>
@@ -6729,7 +6729,7 @@
           <p:cNvPr id="15" name="">
             <a:extLst xmlns:a="http://schemas.openxmlformats.org/drawingml/2006/main">
               <a:ext uri="{FF2B5EF4-FFF2-40B4-BE49-F238E27FC236}">
-                <a16:creationId xmlns:a16="http://schemas.microsoft.com/office/drawing/2014/main" id="{37979D01-B9BB-41DF-AE23-8A2DF9302446}"/>
+                <a16:creationId xmlns:a16="http://schemas.microsoft.com/office/drawing/2014/main" id="{6E4AD160-F25D-4745-9C01-C48C2738BB33}"/>
               </a:ext>
             </a:extLst>
           </p:cNvPr>
@@ -6765,7 +6765,7 @@
                   <a:srgbClr val="FF9A86"/>
                 </a:solidFill>
               </a:rPr>
-              <a:t>Did it scan more than the task needed?</a:t>
+              <a:t>Did it overscan or repeat discovery work?</a:t>
             </a:r>
           </a:p>
         </p:txBody>
@@ -6775,7 +6775,7 @@
           <p:cNvPr id="16" name="">
             <a:extLst xmlns:a="http://schemas.openxmlformats.org/drawingml/2006/main">
               <a:ext uri="{FF2B5EF4-FFF2-40B4-BE49-F238E27FC236}">
-                <a16:creationId xmlns:a16="http://schemas.microsoft.com/office/drawing/2014/main" id="{704EDDC7-7FFB-4D79-9ECE-C404F9FF6022}"/>
+                <a16:creationId xmlns:a16="http://schemas.microsoft.com/office/drawing/2014/main" id="{C8B30FC1-AA6A-4AE2-BD0E-3CBF35E600F6}"/>
               </a:ext>
             </a:extLst>
           </p:cNvPr>
@@ -6811,7 +6811,7 @@
                   <a:srgbClr val="8BE28B"/>
                 </a:solidFill>
               </a:rPr>
-              <a:t>Did it stay inside the named slice?</a:t>
+              <a:t>Did it create clean reusable artifacts?</a:t>
             </a:r>
           </a:p>
         </p:txBody>
@@ -6821,7 +6821,7 @@
           <p:cNvPr id="17" name="">
             <a:extLst xmlns:a="http://schemas.openxmlformats.org/drawingml/2006/main">
               <a:ext uri="{FF2B5EF4-FFF2-40B4-BE49-F238E27FC236}">
-                <a16:creationId xmlns:a16="http://schemas.microsoft.com/office/drawing/2014/main" id="{AC83757B-3EAB-43B4-A550-8E32ADA706DF}"/>
+                <a16:creationId xmlns:a16="http://schemas.microsoft.com/office/drawing/2014/main" id="{31D55FEF-C6F0-4B83-A53D-A9428B58B1C1}"/>
               </a:ext>
             </a:extLst>
           </p:cNvPr>
@@ -6856,7 +6856,7 @@
           <p:cNvPr id="18" name="">
             <a:extLst xmlns:a="http://schemas.openxmlformats.org/drawingml/2006/main">
               <a:ext uri="{FF2B5EF4-FFF2-40B4-BE49-F238E27FC236}">
-                <a16:creationId xmlns:a16="http://schemas.microsoft.com/office/drawing/2014/main" id="{6AF8836E-A183-4A72-B6D2-BC02E64CCE1E}"/>
+                <a16:creationId xmlns:a16="http://schemas.microsoft.com/office/drawing/2014/main" id="{B73D48FA-0FA6-46A0-8709-3335101F90A3}"/>
               </a:ext>
             </a:extLst>
           </p:cNvPr>
@@ -6891,7 +6891,7 @@
           <p:cNvPr id="19" name="">
             <a:extLst xmlns:a="http://schemas.openxmlformats.org/drawingml/2006/main">
               <a:ext uri="{FF2B5EF4-FFF2-40B4-BE49-F238E27FC236}">
-                <a16:creationId xmlns:a16="http://schemas.microsoft.com/office/drawing/2014/main" id="{E704BCEE-FF8F-4AC8-A479-400C1C2B59D5}"/>
+                <a16:creationId xmlns:a16="http://schemas.microsoft.com/office/drawing/2014/main" id="{418C335D-2477-4CE4-859D-AF4C2B81886F}"/>
               </a:ext>
             </a:extLst>
           </p:cNvPr>
@@ -6926,7 +6926,7 @@
           <p:cNvPr id="20" name="">
             <a:extLst xmlns:a="http://schemas.openxmlformats.org/drawingml/2006/main">
               <a:ext uri="{FF2B5EF4-FFF2-40B4-BE49-F238E27FC236}">
-                <a16:creationId xmlns:a16="http://schemas.microsoft.com/office/drawing/2014/main" id="{068FE0FC-E68E-4B68-AC69-2B046C90156D}"/>
+                <a16:creationId xmlns:a16="http://schemas.microsoft.com/office/drawing/2014/main" id="{75FE38B2-7D93-416C-8422-AC9661A4E64C}"/>
               </a:ext>
             </a:extLst>
           </p:cNvPr>
@@ -6962,7 +6962,7 @@
                   <a:srgbClr val="F5F6F7"/>
                 </a:solidFill>
               </a:rPr>
-              <a:t>Repeated scans</a:t>
+              <a:t>Session 2 reuse</a:t>
             </a:r>
           </a:p>
         </p:txBody>
@@ -6972,7 +6972,7 @@
           <p:cNvPr id="21" name="">
             <a:extLst xmlns:a="http://schemas.openxmlformats.org/drawingml/2006/main">
               <a:ext uri="{FF2B5EF4-FFF2-40B4-BE49-F238E27FC236}">
-                <a16:creationId xmlns:a16="http://schemas.microsoft.com/office/drawing/2014/main" id="{A19A0234-C4EE-4A02-ADDE-546C3267553E}"/>
+                <a16:creationId xmlns:a16="http://schemas.microsoft.com/office/drawing/2014/main" id="{A8273768-2CC6-4619-8EED-5D9499FF8FE3}"/>
               </a:ext>
             </a:extLst>
           </p:cNvPr>
@@ -7008,7 +7008,7 @@
                   <a:srgbClr val="FF9A86"/>
                 </a:solidFill>
               </a:rPr>
-              <a:t>Did it rediscover context it already had?</a:t>
+              <a:t>Did it rediscover the repo from scratch?</a:t>
             </a:r>
           </a:p>
         </p:txBody>
@@ -7018,7 +7018,7 @@
           <p:cNvPr id="22" name="">
             <a:extLst xmlns:a="http://schemas.openxmlformats.org/drawingml/2006/main">
               <a:ext uri="{FF2B5EF4-FFF2-40B4-BE49-F238E27FC236}">
-                <a16:creationId xmlns:a16="http://schemas.microsoft.com/office/drawing/2014/main" id="{83970ADF-33ED-45CF-899D-9CDBBD7AD242}"/>
+                <a16:creationId xmlns:a16="http://schemas.microsoft.com/office/drawing/2014/main" id="{542FAC1B-8472-446C-A4C2-C456EFB3DD86}"/>
               </a:ext>
             </a:extLst>
           </p:cNvPr>
@@ -7054,7 +7054,7 @@
                   <a:srgbClr val="8BE28B"/>
                 </a:solidFill>
               </a:rPr>
-              <a:t>Did it reuse repo map and lineage notes?</a:t>
+              <a:t>Did it exploit AGENTS.md and notes quickly?</a:t>
             </a:r>
           </a:p>
         </p:txBody>
@@ -7064,7 +7064,7 @@
           <p:cNvPr id="23" name="">
             <a:extLst xmlns:a="http://schemas.openxmlformats.org/drawingml/2006/main">
               <a:ext uri="{FF2B5EF4-FFF2-40B4-BE49-F238E27FC236}">
-                <a16:creationId xmlns:a16="http://schemas.microsoft.com/office/drawing/2014/main" id="{392C0733-5B71-457D-AD59-0C0D3780DF03}"/>
+                <a16:creationId xmlns:a16="http://schemas.microsoft.com/office/drawing/2014/main" id="{A2670342-DBED-4BA6-AECA-5740D3B6FB48}"/>
               </a:ext>
             </a:extLst>
           </p:cNvPr>
@@ -7099,7 +7099,7 @@
           <p:cNvPr id="24" name="">
             <a:extLst xmlns:a="http://schemas.openxmlformats.org/drawingml/2006/main">
               <a:ext uri="{FF2B5EF4-FFF2-40B4-BE49-F238E27FC236}">
-                <a16:creationId xmlns:a16="http://schemas.microsoft.com/office/drawing/2014/main" id="{616D83AD-B302-4C9D-9FAD-E6BB3CAB02BF}"/>
+                <a16:creationId xmlns:a16="http://schemas.microsoft.com/office/drawing/2014/main" id="{9FA643B5-D5EC-4CC9-B1D7-404B778BACE4}"/>
               </a:ext>
             </a:extLst>
           </p:cNvPr>
@@ -7134,7 +7134,7 @@
           <p:cNvPr id="25" name="">
             <a:extLst xmlns:a="http://schemas.openxmlformats.org/drawingml/2006/main">
               <a:ext uri="{FF2B5EF4-FFF2-40B4-BE49-F238E27FC236}">
-                <a16:creationId xmlns:a16="http://schemas.microsoft.com/office/drawing/2014/main" id="{C9E61806-5004-48D1-88F2-0696F501E37F}"/>
+                <a16:creationId xmlns:a16="http://schemas.microsoft.com/office/drawing/2014/main" id="{0AEFD49A-5D34-47F4-A59A-A3B00099D89C}"/>
               </a:ext>
             </a:extLst>
           </p:cNvPr>
@@ -7169,7 +7169,7 @@
           <p:cNvPr id="26" name="">
             <a:extLst xmlns:a="http://schemas.openxmlformats.org/drawingml/2006/main">
               <a:ext uri="{FF2B5EF4-FFF2-40B4-BE49-F238E27FC236}">
-                <a16:creationId xmlns:a16="http://schemas.microsoft.com/office/drawing/2014/main" id="{D13C6D98-D62A-41EC-B18A-39E5EDDEB068}"/>
+                <a16:creationId xmlns:a16="http://schemas.microsoft.com/office/drawing/2014/main" id="{B4332B4B-5F53-4B7B-B2E8-4DF870597C9F}"/>
               </a:ext>
             </a:extLst>
           </p:cNvPr>
@@ -7205,7 +7205,7 @@
                   <a:srgbClr val="F5F6F7"/>
                 </a:solidFill>
               </a:rPr>
-              <a:t>Changed-file count</a:t>
+              <a:t>Combined token cost</a:t>
             </a:r>
           </a:p>
         </p:txBody>
@@ -7215,7 +7215,7 @@
           <p:cNvPr id="27" name="">
             <a:extLst xmlns:a="http://schemas.openxmlformats.org/drawingml/2006/main">
               <a:ext uri="{FF2B5EF4-FFF2-40B4-BE49-F238E27FC236}">
-                <a16:creationId xmlns:a16="http://schemas.microsoft.com/office/drawing/2014/main" id="{3077940E-DF43-458B-802D-84966900EC81}"/>
+                <a16:creationId xmlns:a16="http://schemas.microsoft.com/office/drawing/2014/main" id="{A50DD9EE-E6C9-469F-BB66-83A6727D16E4}"/>
               </a:ext>
             </a:extLst>
           </p:cNvPr>
@@ -7251,7 +7251,7 @@
                   <a:srgbClr val="FF9A86"/>
                 </a:solidFill>
               </a:rPr>
-              <a:t>Did it wander into unrelated models?</a:t>
+              <a:t>Did prompt overhead stay expensive twice?</a:t>
             </a:r>
           </a:p>
         </p:txBody>
@@ -7261,7 +7261,7 @@
           <p:cNvPr id="28" name="">
             <a:extLst xmlns:a="http://schemas.openxmlformats.org/drawingml/2006/main">
               <a:ext uri="{FF2B5EF4-FFF2-40B4-BE49-F238E27FC236}">
-                <a16:creationId xmlns:a16="http://schemas.microsoft.com/office/drawing/2014/main" id="{89988AB7-5D34-4A93-9015-904418B23777}"/>
+                <a16:creationId xmlns:a16="http://schemas.microsoft.com/office/drawing/2014/main" id="{E77FE68E-01A9-4EE1-A7B2-F63AB44A4FFE}"/>
               </a:ext>
             </a:extLst>
           </p:cNvPr>
@@ -7297,7 +7297,7 @@
                   <a:srgbClr val="8BE28B"/>
                 </a:solidFill>
               </a:rPr>
-              <a:t>Did it keep the edit set minimal?</a:t>
+              <a:t>Did reuse lower uncached token waste?</a:t>
             </a:r>
           </a:p>
         </p:txBody>
@@ -7307,7 +7307,7 @@
           <p:cNvPr id="29" name="">
             <a:extLst xmlns:a="http://schemas.openxmlformats.org/drawingml/2006/main">
               <a:ext uri="{FF2B5EF4-FFF2-40B4-BE49-F238E27FC236}">
-                <a16:creationId xmlns:a16="http://schemas.microsoft.com/office/drawing/2014/main" id="{61895841-71FA-4C26-9F2F-F9039D8AF9E6}"/>
+                <a16:creationId xmlns:a16="http://schemas.microsoft.com/office/drawing/2014/main" id="{4828B6D4-0544-4BEA-BA80-C45BCA7D4601}"/>
               </a:ext>
             </a:extLst>
           </p:cNvPr>
@@ -7342,7 +7342,7 @@
           <p:cNvPr id="30" name="">
             <a:extLst xmlns:a="http://schemas.openxmlformats.org/drawingml/2006/main">
               <a:ext uri="{FF2B5EF4-FFF2-40B4-BE49-F238E27FC236}">
-                <a16:creationId xmlns:a16="http://schemas.microsoft.com/office/drawing/2014/main" id="{F683AC76-070B-47F0-A421-CA1CCBC56969}"/>
+                <a16:creationId xmlns:a16="http://schemas.microsoft.com/office/drawing/2014/main" id="{E4542F37-B27B-4BEA-9C85-9242B6D01EB8}"/>
               </a:ext>
             </a:extLst>
           </p:cNvPr>
@@ -7377,7 +7377,7 @@
           <p:cNvPr id="31" name="">
             <a:extLst xmlns:a="http://schemas.openxmlformats.org/drawingml/2006/main">
               <a:ext uri="{FF2B5EF4-FFF2-40B4-BE49-F238E27FC236}">
-                <a16:creationId xmlns:a16="http://schemas.microsoft.com/office/drawing/2014/main" id="{7D221181-8B06-47C9-A657-6EFD427F93CA}"/>
+                <a16:creationId xmlns:a16="http://schemas.microsoft.com/office/drawing/2014/main" id="{8F38A595-EA47-4016-B7D7-CD9683400D6F}"/>
               </a:ext>
             </a:extLst>
           </p:cNvPr>
@@ -7412,7 +7412,7 @@
           <p:cNvPr id="32" name="">
             <a:extLst xmlns:a="http://schemas.openxmlformats.org/drawingml/2006/main">
               <a:ext uri="{FF2B5EF4-FFF2-40B4-BE49-F238E27FC236}">
-                <a16:creationId xmlns:a16="http://schemas.microsoft.com/office/drawing/2014/main" id="{FB279703-58BA-4F3A-96D3-4B17D48BEDB1}"/>
+                <a16:creationId xmlns:a16="http://schemas.microsoft.com/office/drawing/2014/main" id="{6214C28D-4980-416F-864F-9AC5BBCE6366}"/>
               </a:ext>
             </a:extLst>
           </p:cNvPr>
@@ -7458,7 +7458,7 @@
           <p:cNvPr id="33" name="">
             <a:extLst xmlns:a="http://schemas.openxmlformats.org/drawingml/2006/main">
               <a:ext uri="{FF2B5EF4-FFF2-40B4-BE49-F238E27FC236}">
-                <a16:creationId xmlns:a16="http://schemas.microsoft.com/office/drawing/2014/main" id="{DDAD2711-A3A4-449E-9CFB-52CDEE4E319A}"/>
+                <a16:creationId xmlns:a16="http://schemas.microsoft.com/office/drawing/2014/main" id="{61898D92-FB4A-47DD-A310-62611EEDE20A}"/>
               </a:ext>
             </a:extLst>
           </p:cNvPr>
@@ -7504,7 +7504,7 @@
           <p:cNvPr id="34" name="">
             <a:extLst xmlns:a="http://schemas.openxmlformats.org/drawingml/2006/main">
               <a:ext uri="{FF2B5EF4-FFF2-40B4-BE49-F238E27FC236}">
-                <a16:creationId xmlns:a16="http://schemas.microsoft.com/office/drawing/2014/main" id="{3F1E8262-7145-49F9-B1AB-1C3080D190AB}"/>
+                <a16:creationId xmlns:a16="http://schemas.microsoft.com/office/drawing/2014/main" id="{A5257998-A1C3-408C-835C-AF56883C4E77}"/>
               </a:ext>
             </a:extLst>
           </p:cNvPr>
@@ -7550,7 +7550,7 @@
           <p:cNvPr id="35" name="">
             <a:extLst xmlns:a="http://schemas.openxmlformats.org/drawingml/2006/main">
               <a:ext uri="{FF2B5EF4-FFF2-40B4-BE49-F238E27FC236}">
-                <a16:creationId xmlns:a16="http://schemas.microsoft.com/office/drawing/2014/main" id="{9F7F35FF-EBEE-4C8C-BC9C-94BE9D5645FC}"/>
+                <a16:creationId xmlns:a16="http://schemas.microsoft.com/office/drawing/2014/main" id="{CE40F07C-B22A-45B0-B6C5-CF5A3569622A}"/>
               </a:ext>
             </a:extLst>
           </p:cNvPr>
@@ -7585,7 +7585,7 @@
           <p:cNvPr id="36" name="">
             <a:extLst xmlns:a="http://schemas.openxmlformats.org/drawingml/2006/main">
               <a:ext uri="{FF2B5EF4-FFF2-40B4-BE49-F238E27FC236}">
-                <a16:creationId xmlns:a16="http://schemas.microsoft.com/office/drawing/2014/main" id="{50563823-1E2E-48B7-AD3A-B99EE5DA4ACB}"/>
+                <a16:creationId xmlns:a16="http://schemas.microsoft.com/office/drawing/2014/main" id="{97623452-38B1-42D7-876A-1D1BCD54600E}"/>
               </a:ext>
             </a:extLst>
           </p:cNvPr>
@@ -7620,7 +7620,7 @@
           <p:cNvPr id="37" name="">
             <a:extLst xmlns:a="http://schemas.openxmlformats.org/drawingml/2006/main">
               <a:ext uri="{FF2B5EF4-FFF2-40B4-BE49-F238E27FC236}">
-                <a16:creationId xmlns:a16="http://schemas.microsoft.com/office/drawing/2014/main" id="{0D361700-74FE-4EC7-A77B-FD315FDDA6CA}"/>
+                <a16:creationId xmlns:a16="http://schemas.microsoft.com/office/drawing/2014/main" id="{B0301E93-40BE-482E-B188-FA013A45A6FC}"/>
               </a:ext>
             </a:extLst>
           </p:cNvPr>
@@ -7655,7 +7655,7 @@
           <p:cNvPr id="38" name="">
             <a:extLst xmlns:a="http://schemas.openxmlformats.org/drawingml/2006/main">
               <a:ext uri="{FF2B5EF4-FFF2-40B4-BE49-F238E27FC236}">
-                <a16:creationId xmlns:a16="http://schemas.microsoft.com/office/drawing/2014/main" id="{50DED85E-98F0-42E5-B4B6-85C5C2D71390}"/>
+                <a16:creationId xmlns:a16="http://schemas.microsoft.com/office/drawing/2014/main" id="{37655D88-9234-4BE9-9589-C65E139CA2A7}"/>
               </a:ext>
             </a:extLst>
           </p:cNvPr>
@@ -7701,7 +7701,7 @@
           <p:cNvPr id="39" name="">
             <a:extLst xmlns:a="http://schemas.openxmlformats.org/drawingml/2006/main">
               <a:ext uri="{FF2B5EF4-FFF2-40B4-BE49-F238E27FC236}">
-                <a16:creationId xmlns:a16="http://schemas.microsoft.com/office/drawing/2014/main" id="{87E68DDB-6ABA-4CCF-B76F-BD134F9CABFE}"/>
+                <a16:creationId xmlns:a16="http://schemas.microsoft.com/office/drawing/2014/main" id="{5D92EBCB-9C26-437D-9F91-3203A5AD74D4}"/>
               </a:ext>
             </a:extLst>
           </p:cNvPr>
@@ -7747,7 +7747,7 @@
           <p:cNvPr id="40" name="">
             <a:extLst xmlns:a="http://schemas.openxmlformats.org/drawingml/2006/main">
               <a:ext uri="{FF2B5EF4-FFF2-40B4-BE49-F238E27FC236}">
-                <a16:creationId xmlns:a16="http://schemas.microsoft.com/office/drawing/2014/main" id="{DE050184-F9AA-4C28-A033-0CE1D8E9875C}"/>
+                <a16:creationId xmlns:a16="http://schemas.microsoft.com/office/drawing/2014/main" id="{649456AE-AABF-4E9C-94DC-43B5A5F7A313}"/>
               </a:ext>
             </a:extLst>
           </p:cNvPr>
@@ -7791,7 +7791,7 @@
     </p:spTree>
     <p:extLst>
       <p:ext uri="{BB962C8B-B14F-4D97-AF65-F5344CB8AC3E}">
-        <p14:creationId xmlns:p14="http://schemas.microsoft.com/office/powerpoint/2010/main" val="1500104240"/>
+        <p14:creationId xmlns:p14="http://schemas.microsoft.com/office/powerpoint/2010/main" val="1469294679"/>
       </p:ext>
     </p:extLst>
   </p:cSld>
@@ -7822,7 +7822,7 @@
           <p:cNvPr id="1" name="">
             <a:extLst xmlns:a="http://schemas.openxmlformats.org/drawingml/2006/main">
               <a:ext uri="{FF2B5EF4-FFF2-40B4-BE49-F238E27FC236}">
-                <a16:creationId xmlns:a16="http://schemas.microsoft.com/office/drawing/2014/main" id="{1BCAA154-3C6C-4835-9D6D-36025CBB6A6C}"/>
+                <a16:creationId xmlns:a16="http://schemas.microsoft.com/office/drawing/2014/main" id="{EFA6C3E3-8A7C-4182-8D87-DD20BAB3F9C8}"/>
               </a:ext>
             </a:extLst>
           </p:cNvPr>
@@ -7852,7 +7852,7 @@
           <p:cNvPr id="2" name="">
             <a:extLst xmlns:a="http://schemas.openxmlformats.org/drawingml/2006/main">
               <a:ext uri="{FF2B5EF4-FFF2-40B4-BE49-F238E27FC236}">
-                <a16:creationId xmlns:a16="http://schemas.microsoft.com/office/drawing/2014/main" id="{3A07E9D1-5186-42D6-9B2F-81DD437152A6}"/>
+                <a16:creationId xmlns:a16="http://schemas.microsoft.com/office/drawing/2014/main" id="{5B372810-E343-4994-8997-2D3F3B847492}"/>
               </a:ext>
             </a:extLst>
           </p:cNvPr>
@@ -7898,7 +7898,7 @@
           <p:cNvPr id="3" name="">
             <a:extLst xmlns:a="http://schemas.openxmlformats.org/drawingml/2006/main">
               <a:ext uri="{FF2B5EF4-FFF2-40B4-BE49-F238E27FC236}">
-                <a16:creationId xmlns:a16="http://schemas.microsoft.com/office/drawing/2014/main" id="{BFB269BE-5035-445D-82E2-D90632A7E33A}"/>
+                <a16:creationId xmlns:a16="http://schemas.microsoft.com/office/drawing/2014/main" id="{3C0C3FE9-B771-4307-8DBC-538FC76558C1}"/>
               </a:ext>
             </a:extLst>
           </p:cNvPr>
@@ -7934,7 +7934,7 @@
                   <a:srgbClr val="F5F6F7"/>
                 </a:solidFill>
               </a:rPr>
-              <a:t>Rewrite the Demo Prompt, Not Just the Principle</a:t>
+              <a:t>Design For The Next Session, Not Just The First One</a:t>
             </a:r>
           </a:p>
         </p:txBody>
@@ -7944,7 +7944,7 @@
           <p:cNvPr id="4" name="">
             <a:extLst xmlns:a="http://schemas.openxmlformats.org/drawingml/2006/main">
               <a:ext uri="{FF2B5EF4-FFF2-40B4-BE49-F238E27FC236}">
-                <a16:creationId xmlns:a16="http://schemas.microsoft.com/office/drawing/2014/main" id="{25C05C2F-B271-4761-BE67-AFF0158AD81E}"/>
+                <a16:creationId xmlns:a16="http://schemas.microsoft.com/office/drawing/2014/main" id="{59E00DCA-7C22-419B-BE1F-977668150498}"/>
               </a:ext>
             </a:extLst>
           </p:cNvPr>
@@ -7980,7 +7980,7 @@
                   <a:srgbClr val="97A0AA"/>
                 </a:solidFill>
               </a:rPr>
-              <a:t>Use the sandbox repo so attendees practice the exact move they will watch in the live comparison.</a:t>
+              <a:t>Use the sandbox repo so attendees see why disciplined prompts earn their payoff on follow-up work.</a:t>
             </a:r>
           </a:p>
         </p:txBody>
@@ -7990,7 +7990,7 @@
           <p:cNvPr id="5" name="">
             <a:extLst xmlns:a="http://schemas.openxmlformats.org/drawingml/2006/main">
               <a:ext uri="{FF2B5EF4-FFF2-40B4-BE49-F238E27FC236}">
-                <a16:creationId xmlns:a16="http://schemas.microsoft.com/office/drawing/2014/main" id="{74785924-B1A6-4330-BF03-FFF6946BEF59}"/>
+                <a16:creationId xmlns:a16="http://schemas.microsoft.com/office/drawing/2014/main" id="{D67817BF-A21A-4C1B-A96E-4869385C4E73}"/>
               </a:ext>
             </a:extLst>
           </p:cNvPr>
@@ -8025,7 +8025,7 @@
           <p:cNvPr id="6" name="">
             <a:extLst xmlns:a="http://schemas.openxmlformats.org/drawingml/2006/main">
               <a:ext uri="{FF2B5EF4-FFF2-40B4-BE49-F238E27FC236}">
-                <a16:creationId xmlns:a16="http://schemas.microsoft.com/office/drawing/2014/main" id="{EC892218-02A5-4B73-9A4C-78CC9038F83E}"/>
+                <a16:creationId xmlns:a16="http://schemas.microsoft.com/office/drawing/2014/main" id="{17DFECA1-2A5D-417F-AB6F-ECD0D1DCE987}"/>
               </a:ext>
             </a:extLst>
           </p:cNvPr>
@@ -8071,7 +8071,7 @@
           <p:cNvPr id="7" name="">
             <a:extLst xmlns:a="http://schemas.openxmlformats.org/drawingml/2006/main">
               <a:ext uri="{FF2B5EF4-FFF2-40B4-BE49-F238E27FC236}">
-                <a16:creationId xmlns:a16="http://schemas.microsoft.com/office/drawing/2014/main" id="{3E332961-4EAF-4765-BA39-0D134D473B95}"/>
+                <a16:creationId xmlns:a16="http://schemas.microsoft.com/office/drawing/2014/main" id="{C0BF0D6B-E1E4-44A6-B116-FB5FE780EFF3}"/>
               </a:ext>
             </a:extLst>
           </p:cNvPr>
@@ -8117,7 +8117,7 @@
           <p:cNvPr id="8" name="">
             <a:extLst xmlns:a="http://schemas.openxmlformats.org/drawingml/2006/main">
               <a:ext uri="{FF2B5EF4-FFF2-40B4-BE49-F238E27FC236}">
-                <a16:creationId xmlns:a16="http://schemas.microsoft.com/office/drawing/2014/main" id="{817568CF-3293-4BCD-B0E2-8EA736B7BB23}"/>
+                <a16:creationId xmlns:a16="http://schemas.microsoft.com/office/drawing/2014/main" id="{DB40840D-0242-4659-BF3B-095FCEFE3DEF}"/>
               </a:ext>
             </a:extLst>
           </p:cNvPr>
@@ -8152,7 +8152,7 @@
           <p:cNvPr id="9" name="">
             <a:extLst xmlns:a="http://schemas.openxmlformats.org/drawingml/2006/main">
               <a:ext uri="{FF2B5EF4-FFF2-40B4-BE49-F238E27FC236}">
-                <a16:creationId xmlns:a16="http://schemas.microsoft.com/office/drawing/2014/main" id="{A589B0D9-459C-4D90-9093-696242EFAA2D}"/>
+                <a16:creationId xmlns:a16="http://schemas.microsoft.com/office/drawing/2014/main" id="{71095348-0FD0-425E-9A16-76C1E91509B7}"/>
               </a:ext>
             </a:extLst>
           </p:cNvPr>
@@ -8198,7 +8198,7 @@
           <p:cNvPr id="10" name="">
             <a:extLst xmlns:a="http://schemas.openxmlformats.org/drawingml/2006/main">
               <a:ext uri="{FF2B5EF4-FFF2-40B4-BE49-F238E27FC236}">
-                <a16:creationId xmlns:a16="http://schemas.microsoft.com/office/drawing/2014/main" id="{47690BAA-A601-4305-A13D-1B6C66044885}"/>
+                <a16:creationId xmlns:a16="http://schemas.microsoft.com/office/drawing/2014/main" id="{CC3326CF-2237-4FDD-A0C2-A34D5D859141}"/>
               </a:ext>
             </a:extLst>
           </p:cNvPr>
@@ -8244,7 +8244,7 @@
           <p:cNvPr id="11" name="">
             <a:extLst xmlns:a="http://schemas.openxmlformats.org/drawingml/2006/main">
               <a:ext uri="{FF2B5EF4-FFF2-40B4-BE49-F238E27FC236}">
-                <a16:creationId xmlns:a16="http://schemas.microsoft.com/office/drawing/2014/main" id="{53BDE072-8CF2-492F-8587-F64511B64936}"/>
+                <a16:creationId xmlns:a16="http://schemas.microsoft.com/office/drawing/2014/main" id="{445D5D24-FCA2-47B4-B45C-8853D86310CA}"/>
               </a:ext>
             </a:extLst>
           </p:cNvPr>
@@ -8280,7 +8280,7 @@
                   <a:srgbClr val="D6D8DC"/>
                 </a:solidFill>
               </a:rPr>
-              <a:t>• Require a plan before edits.</a:t>
+              <a:t>• Require reusable artifacts in session 1.</a:t>
             </a:r>
           </a:p>
         </p:txBody>
@@ -8290,7 +8290,7 @@
           <p:cNvPr id="12" name="">
             <a:extLst xmlns:a="http://schemas.openxmlformats.org/drawingml/2006/main">
               <a:ext uri="{FF2B5EF4-FFF2-40B4-BE49-F238E27FC236}">
-                <a16:creationId xmlns:a16="http://schemas.microsoft.com/office/drawing/2014/main" id="{169DF29E-023D-4701-9226-B1C101B63820}"/>
+                <a16:creationId xmlns:a16="http://schemas.microsoft.com/office/drawing/2014/main" id="{A40E8A8E-FD13-4B4E-B90F-716BA78EB14B}"/>
               </a:ext>
             </a:extLst>
           </p:cNvPr>
@@ -8326,7 +8326,7 @@
                   <a:srgbClr val="D6D8DC"/>
                 </a:solidFill>
               </a:rPr>
-              <a:t>• Reuse docs/dbt_lineage_notes.md first.</a:t>
+              <a:t>• Make session 2 reuse those artifacts from a fresh chat.</a:t>
             </a:r>
           </a:p>
         </p:txBody>
@@ -8336,7 +8336,7 @@
           <p:cNvPr id="13" name="">
             <a:extLst xmlns:a="http://schemas.openxmlformats.org/drawingml/2006/main">
               <a:ext uri="{FF2B5EF4-FFF2-40B4-BE49-F238E27FC236}">
-                <a16:creationId xmlns:a16="http://schemas.microsoft.com/office/drawing/2014/main" id="{DC4DB9EE-F3EF-4478-9447-CCBA0768F5B8}"/>
+                <a16:creationId xmlns:a16="http://schemas.microsoft.com/office/drawing/2014/main" id="{C99D0405-46E5-4B61-8536-A8DE008813DD}"/>
               </a:ext>
             </a:extLst>
           </p:cNvPr>
@@ -8382,7 +8382,7 @@
           <p:cNvPr id="14" name="">
             <a:extLst xmlns:a="http://schemas.openxmlformats.org/drawingml/2006/main">
               <a:ext uri="{FF2B5EF4-FFF2-40B4-BE49-F238E27FC236}">
-                <a16:creationId xmlns:a16="http://schemas.microsoft.com/office/drawing/2014/main" id="{049AA867-9135-4669-9BA3-A24E3799BD5E}"/>
+                <a16:creationId xmlns:a16="http://schemas.microsoft.com/office/drawing/2014/main" id="{26B1E003-4A4F-47EC-8958-22C7A68E445B}"/>
               </a:ext>
             </a:extLst>
           </p:cNvPr>
@@ -8428,7 +8428,7 @@
           <p:cNvPr id="15" name="">
             <a:extLst xmlns:a="http://schemas.openxmlformats.org/drawingml/2006/main">
               <a:ext uri="{FF2B5EF4-FFF2-40B4-BE49-F238E27FC236}">
-                <a16:creationId xmlns:a16="http://schemas.microsoft.com/office/drawing/2014/main" id="{1A88D316-74D5-47C6-B9A8-051536DE93EA}"/>
+                <a16:creationId xmlns:a16="http://schemas.microsoft.com/office/drawing/2014/main" id="{913B340E-1FF9-4250-AD02-25CBB62E945B}"/>
               </a:ext>
             </a:extLst>
           </p:cNvPr>
@@ -8464,7 +8464,7 @@
                   <a:srgbClr val="D6D8DC"/>
                 </a:solidFill>
               </a:rPr>
-              <a:t>1. careless prompt  2. scoped rewrite  3. allowed files  4. ignored files  5. reusable artifact  6. validation step</a:t>
+              <a:t>1. session 1 vague prompt  2. disciplined rewrite  3. session 1 artifacts  4. fresh-session follow-up  5. validation step  6. combined metric</a:t>
             </a:r>
           </a:p>
         </p:txBody>
@@ -8472,7 +8472,7 @@
     </p:spTree>
     <p:extLst>
       <p:ext uri="{BB962C8B-B14F-4D97-AF65-F5344CB8AC3E}">
-        <p14:creationId xmlns:p14="http://schemas.microsoft.com/office/powerpoint/2010/main" val="1913348654"/>
+        <p14:creationId xmlns:p14="http://schemas.microsoft.com/office/powerpoint/2010/main" val="1506215822"/>
       </p:ext>
     </p:extLst>
   </p:cSld>
@@ -8503,7 +8503,7 @@
           <p:cNvPr id="2" name="Shape 0">
             <a:extLst xmlns:a="http://schemas.openxmlformats.org/drawingml/2006/main">
               <a:ext uri="{FF2B5EF4-FFF2-40B4-BE49-F238E27FC236}">
-                <a16:creationId xmlns:a16="http://schemas.microsoft.com/office/drawing/2014/main" id="{EEE04C99-360C-4CF3-9945-A6835302B883}"/>
+                <a16:creationId xmlns:a16="http://schemas.microsoft.com/office/drawing/2014/main" id="{4056ED5E-68E1-4ACE-B3D6-BF18627E9DB2}"/>
               </a:ext>
             </a:extLst>
           </p:cNvPr>
@@ -8536,7 +8536,7 @@
           <p:cNvPr id="3" name="Text 1">
             <a:extLst xmlns:a="http://schemas.openxmlformats.org/drawingml/2006/main">
               <a:ext uri="{FF2B5EF4-FFF2-40B4-BE49-F238E27FC236}">
-                <a16:creationId xmlns:a16="http://schemas.microsoft.com/office/drawing/2014/main" id="{C725528B-7783-4EDE-BF2C-83493374141A}"/>
+                <a16:creationId xmlns:a16="http://schemas.microsoft.com/office/drawing/2014/main" id="{A4E72E5D-291B-43DC-84B5-4983C48A6139}"/>
               </a:ext>
             </a:extLst>
           </p:cNvPr>
@@ -8583,7 +8583,7 @@
           <p:cNvPr id="4" name="Text 2">
             <a:extLst xmlns:a="http://schemas.openxmlformats.org/drawingml/2006/main">
               <a:ext uri="{FF2B5EF4-FFF2-40B4-BE49-F238E27FC236}">
-                <a16:creationId xmlns:a16="http://schemas.microsoft.com/office/drawing/2014/main" id="{97266370-C2F1-46CC-B93C-8A846551B30E}"/>
+                <a16:creationId xmlns:a16="http://schemas.microsoft.com/office/drawing/2014/main" id="{816AF9EE-DD84-4911-BAAA-EE1F5C5FF4AD}"/>
               </a:ext>
             </a:extLst>
           </p:cNvPr>
@@ -8630,7 +8630,7 @@
           <p:cNvPr id="5" name="Shape 3">
             <a:extLst xmlns:a="http://schemas.openxmlformats.org/drawingml/2006/main">
               <a:ext uri="{FF2B5EF4-FFF2-40B4-BE49-F238E27FC236}">
-                <a16:creationId xmlns:a16="http://schemas.microsoft.com/office/drawing/2014/main" id="{6D7812BD-F8E1-4BD0-8B5D-0AF345882377}"/>
+                <a16:creationId xmlns:a16="http://schemas.microsoft.com/office/drawing/2014/main" id="{39E486D2-4903-4590-85C6-6DAED47A945B}"/>
               </a:ext>
             </a:extLst>
           </p:cNvPr>
@@ -8661,7 +8661,7 @@
           <p:cNvPr id="6" name="Text 4">
             <a:extLst xmlns:a="http://schemas.openxmlformats.org/drawingml/2006/main">
               <a:ext uri="{FF2B5EF4-FFF2-40B4-BE49-F238E27FC236}">
-                <a16:creationId xmlns:a16="http://schemas.microsoft.com/office/drawing/2014/main" id="{A3650608-15A2-4E4F-86A2-2AA07FEA3CEC}"/>
+                <a16:creationId xmlns:a16="http://schemas.microsoft.com/office/drawing/2014/main" id="{1632157A-1046-4A6A-9BE0-157876945B15}"/>
               </a:ext>
             </a:extLst>
           </p:cNvPr>
@@ -8736,7 +8736,7 @@
           <p:cNvPr id="7" name="Text 5">
             <a:extLst xmlns:a="http://schemas.openxmlformats.org/drawingml/2006/main">
               <a:ext uri="{FF2B5EF4-FFF2-40B4-BE49-F238E27FC236}">
-                <a16:creationId xmlns:a16="http://schemas.microsoft.com/office/drawing/2014/main" id="{379BEE74-9CF9-43F8-A97D-5215F640FDF0}"/>
+                <a16:creationId xmlns:a16="http://schemas.microsoft.com/office/drawing/2014/main" id="{B0F88B1E-097A-4784-9131-9BE9BC486A5E}"/>
               </a:ext>
             </a:extLst>
           </p:cNvPr>
@@ -8891,7 +8891,7 @@
           <p:cNvPr id="8" name="Text 6">
             <a:extLst xmlns:a="http://schemas.openxmlformats.org/drawingml/2006/main">
               <a:ext uri="{FF2B5EF4-FFF2-40B4-BE49-F238E27FC236}">
-                <a16:creationId xmlns:a16="http://schemas.microsoft.com/office/drawing/2014/main" id="{5FFFDBFC-8DB4-4915-B077-B405E9500071}"/>
+                <a16:creationId xmlns:a16="http://schemas.microsoft.com/office/drawing/2014/main" id="{DA55A670-0C25-42FD-BB6B-BB7D081F9BA2}"/>
               </a:ext>
             </a:extLst>
           </p:cNvPr>
@@ -8964,7 +8964,7 @@
     </p:spTree>
     <p:extLst>
       <p:ext uri="{BB962C8B-B14F-4D97-AF65-F5344CB8AC3E}">
-        <p14:creationId xmlns:p14="http://schemas.microsoft.com/office/powerpoint/2010/main" val="112462918"/>
+        <p14:creationId xmlns:p14="http://schemas.microsoft.com/office/powerpoint/2010/main" val="55631377"/>
       </p:ext>
     </p:extLst>
   </p:cSld>
@@ -8995,7 +8995,7 @@
           <p:cNvPr id="2" name="Shape 0">
             <a:extLst xmlns:a="http://schemas.openxmlformats.org/drawingml/2006/main">
               <a:ext uri="{FF2B5EF4-FFF2-40B4-BE49-F238E27FC236}">
-                <a16:creationId xmlns:a16="http://schemas.microsoft.com/office/drawing/2014/main" id="{C544204C-2A2E-452C-B2E4-C069B093C47B}"/>
+                <a16:creationId xmlns:a16="http://schemas.microsoft.com/office/drawing/2014/main" id="{AD2CD504-4808-4F89-900F-EBDBD40E8672}"/>
               </a:ext>
             </a:extLst>
           </p:cNvPr>
@@ -9028,7 +9028,7 @@
           <p:cNvPr id="3" name="Text 1">
             <a:extLst xmlns:a="http://schemas.openxmlformats.org/drawingml/2006/main">
               <a:ext uri="{FF2B5EF4-FFF2-40B4-BE49-F238E27FC236}">
-                <a16:creationId xmlns:a16="http://schemas.microsoft.com/office/drawing/2014/main" id="{819ACFE9-00B1-45DB-9C0D-CAFB423FD891}"/>
+                <a16:creationId xmlns:a16="http://schemas.microsoft.com/office/drawing/2014/main" id="{F1124B6F-77F9-4820-A2AF-CEE17B9DCEF1}"/>
               </a:ext>
             </a:extLst>
           </p:cNvPr>
@@ -9075,7 +9075,7 @@
           <p:cNvPr id="4" name="Text 2">
             <a:extLst xmlns:a="http://schemas.openxmlformats.org/drawingml/2006/main">
               <a:ext uri="{FF2B5EF4-FFF2-40B4-BE49-F238E27FC236}">
-                <a16:creationId xmlns:a16="http://schemas.microsoft.com/office/drawing/2014/main" id="{23B45C8C-28FF-4754-9CB4-0022CF1B3D25}"/>
+                <a16:creationId xmlns:a16="http://schemas.microsoft.com/office/drawing/2014/main" id="{EC38F448-0E0D-4D12-B2D4-BCDD48CBBA35}"/>
               </a:ext>
             </a:extLst>
           </p:cNvPr>
@@ -9122,7 +9122,7 @@
           <p:cNvPr id="5" name="Shape 3">
             <a:extLst xmlns:a="http://schemas.openxmlformats.org/drawingml/2006/main">
               <a:ext uri="{FF2B5EF4-FFF2-40B4-BE49-F238E27FC236}">
-                <a16:creationId xmlns:a16="http://schemas.microsoft.com/office/drawing/2014/main" id="{D83DEF77-5E2B-423C-A1EA-B89F9A0D1C9A}"/>
+                <a16:creationId xmlns:a16="http://schemas.microsoft.com/office/drawing/2014/main" id="{74FC6B01-445A-4E10-B3BB-CB3299432A3D}"/>
               </a:ext>
             </a:extLst>
           </p:cNvPr>
@@ -9153,7 +9153,7 @@
           <p:cNvPr id="6" name="Text 4">
             <a:extLst xmlns:a="http://schemas.openxmlformats.org/drawingml/2006/main">
               <a:ext uri="{FF2B5EF4-FFF2-40B4-BE49-F238E27FC236}">
-                <a16:creationId xmlns:a16="http://schemas.microsoft.com/office/drawing/2014/main" id="{5061A782-0392-4DC4-BA8E-4D001FDEA759}"/>
+                <a16:creationId xmlns:a16="http://schemas.microsoft.com/office/drawing/2014/main" id="{34112943-DD18-4C52-B3B0-571DD940DA9C}"/>
               </a:ext>
             </a:extLst>
           </p:cNvPr>
@@ -9228,7 +9228,7 @@
           <p:cNvPr id="7" name="Text 5">
             <a:extLst xmlns:a="http://schemas.openxmlformats.org/drawingml/2006/main">
               <a:ext uri="{FF2B5EF4-FFF2-40B4-BE49-F238E27FC236}">
-                <a16:creationId xmlns:a16="http://schemas.microsoft.com/office/drawing/2014/main" id="{0249C6E1-BB0E-4367-99BB-DAE6C22027C6}"/>
+                <a16:creationId xmlns:a16="http://schemas.microsoft.com/office/drawing/2014/main" id="{B87272CD-D295-469C-9079-912107CE3855}"/>
               </a:ext>
             </a:extLst>
           </p:cNvPr>
@@ -9303,7 +9303,7 @@
           <p:cNvPr id="8" name="Text 6">
             <a:extLst xmlns:a="http://schemas.openxmlformats.org/drawingml/2006/main">
               <a:ext uri="{FF2B5EF4-FFF2-40B4-BE49-F238E27FC236}">
-                <a16:creationId xmlns:a16="http://schemas.microsoft.com/office/drawing/2014/main" id="{2CBC665C-AA7C-4605-BD8A-300F91E4CBE5}"/>
+                <a16:creationId xmlns:a16="http://schemas.microsoft.com/office/drawing/2014/main" id="{04C41B22-93C5-404F-A9A8-E35D453CCEEC}"/>
               </a:ext>
             </a:extLst>
           </p:cNvPr>
@@ -9378,7 +9378,7 @@
           <p:cNvPr id="9" name="Text 7">
             <a:extLst xmlns:a="http://schemas.openxmlformats.org/drawingml/2006/main">
               <a:ext uri="{FF2B5EF4-FFF2-40B4-BE49-F238E27FC236}">
-                <a16:creationId xmlns:a16="http://schemas.microsoft.com/office/drawing/2014/main" id="{849DF81D-234C-4059-AF5D-6FF65BD84E4C}"/>
+                <a16:creationId xmlns:a16="http://schemas.microsoft.com/office/drawing/2014/main" id="{D9D9AD7C-9498-45B5-984C-C42CE35CE1F4}"/>
               </a:ext>
             </a:extLst>
           </p:cNvPr>
@@ -9453,7 +9453,7 @@
           <p:cNvPr id="10" name="Text 8">
             <a:extLst xmlns:a="http://schemas.openxmlformats.org/drawingml/2006/main">
               <a:ext uri="{FF2B5EF4-FFF2-40B4-BE49-F238E27FC236}">
-                <a16:creationId xmlns:a16="http://schemas.microsoft.com/office/drawing/2014/main" id="{16EF33BF-E0B9-40BC-957B-879663383103}"/>
+                <a16:creationId xmlns:a16="http://schemas.microsoft.com/office/drawing/2014/main" id="{030F1878-9784-43B1-9DFD-D9690EFC20F6}"/>
               </a:ext>
             </a:extLst>
           </p:cNvPr>
@@ -9498,7 +9498,7 @@
     </p:spTree>
     <p:extLst>
       <p:ext uri="{BB962C8B-B14F-4D97-AF65-F5344CB8AC3E}">
-        <p14:creationId xmlns:p14="http://schemas.microsoft.com/office/powerpoint/2010/main" val="2113562433"/>
+        <p14:creationId xmlns:p14="http://schemas.microsoft.com/office/powerpoint/2010/main" val="846390858"/>
       </p:ext>
     </p:extLst>
   </p:cSld>
@@ -9529,7 +9529,7 @@
           <p:cNvPr id="2" name="Shape 0">
             <a:extLst xmlns:a="http://schemas.openxmlformats.org/drawingml/2006/main">
               <a:ext uri="{FF2B5EF4-FFF2-40B4-BE49-F238E27FC236}">
-                <a16:creationId xmlns:a16="http://schemas.microsoft.com/office/drawing/2014/main" id="{A9821C75-BB80-42AF-A041-537A85A7BEF6}"/>
+                <a16:creationId xmlns:a16="http://schemas.microsoft.com/office/drawing/2014/main" id="{32077D73-E3E5-45CD-8C8D-4FCEFF4F7321}"/>
               </a:ext>
             </a:extLst>
           </p:cNvPr>
@@ -9562,7 +9562,7 @@
           <p:cNvPr id="3" name="Text 1">
             <a:extLst xmlns:a="http://schemas.openxmlformats.org/drawingml/2006/main">
               <a:ext uri="{FF2B5EF4-FFF2-40B4-BE49-F238E27FC236}">
-                <a16:creationId xmlns:a16="http://schemas.microsoft.com/office/drawing/2014/main" id="{85BE9D94-EE05-4345-B74A-34D3F5FFF9B7}"/>
+                <a16:creationId xmlns:a16="http://schemas.microsoft.com/office/drawing/2014/main" id="{B03AE198-0F71-4DE4-A408-74E683B99677}"/>
               </a:ext>
             </a:extLst>
           </p:cNvPr>
@@ -9609,7 +9609,7 @@
           <p:cNvPr id="4" name="Text 2">
             <a:extLst xmlns:a="http://schemas.openxmlformats.org/drawingml/2006/main">
               <a:ext uri="{FF2B5EF4-FFF2-40B4-BE49-F238E27FC236}">
-                <a16:creationId xmlns:a16="http://schemas.microsoft.com/office/drawing/2014/main" id="{E96BE13A-4634-4CD5-B0C6-5A0591B2A086}"/>
+                <a16:creationId xmlns:a16="http://schemas.microsoft.com/office/drawing/2014/main" id="{17759E5A-5FF4-4777-B66F-2BF303538F7A}"/>
               </a:ext>
             </a:extLst>
           </p:cNvPr>
@@ -9656,7 +9656,7 @@
           <p:cNvPr id="5" name="Shape 3">
             <a:extLst xmlns:a="http://schemas.openxmlformats.org/drawingml/2006/main">
               <a:ext uri="{FF2B5EF4-FFF2-40B4-BE49-F238E27FC236}">
-                <a16:creationId xmlns:a16="http://schemas.microsoft.com/office/drawing/2014/main" id="{D54BF4A8-4569-46A7-9366-05AB7167909A}"/>
+                <a16:creationId xmlns:a16="http://schemas.microsoft.com/office/drawing/2014/main" id="{25FC49EB-7DE6-47A1-8CB2-989D9C286DA1}"/>
               </a:ext>
             </a:extLst>
           </p:cNvPr>
@@ -9687,7 +9687,7 @@
           <p:cNvPr id="6" name="Text 4">
             <a:extLst xmlns:a="http://schemas.openxmlformats.org/drawingml/2006/main">
               <a:ext uri="{FF2B5EF4-FFF2-40B4-BE49-F238E27FC236}">
-                <a16:creationId xmlns:a16="http://schemas.microsoft.com/office/drawing/2014/main" id="{0D53B72D-DBE8-4EB3-8731-CE2D0401E2CD}"/>
+                <a16:creationId xmlns:a16="http://schemas.microsoft.com/office/drawing/2014/main" id="{54915415-5F1D-4967-83C7-7192443FFFE3}"/>
               </a:ext>
             </a:extLst>
           </p:cNvPr>
@@ -9810,7 +9810,7 @@
           <p:cNvPr id="7" name="Text 5">
             <a:extLst xmlns:a="http://schemas.openxmlformats.org/drawingml/2006/main">
               <a:ext uri="{FF2B5EF4-FFF2-40B4-BE49-F238E27FC236}">
-                <a16:creationId xmlns:a16="http://schemas.microsoft.com/office/drawing/2014/main" id="{ACCD8899-FE80-4DC6-89F4-895048A5549F}"/>
+                <a16:creationId xmlns:a16="http://schemas.microsoft.com/office/drawing/2014/main" id="{095FDA7A-C41A-4BFE-AF7B-BA946F194469}"/>
               </a:ext>
             </a:extLst>
           </p:cNvPr>
@@ -9973,7 +9973,7 @@
     </p:spTree>
     <p:extLst>
       <p:ext uri="{BB962C8B-B14F-4D97-AF65-F5344CB8AC3E}">
-        <p14:creationId xmlns:p14="http://schemas.microsoft.com/office/powerpoint/2010/main" val="140088071"/>
+        <p14:creationId xmlns:p14="http://schemas.microsoft.com/office/powerpoint/2010/main" val="221232938"/>
       </p:ext>
     </p:extLst>
   </p:cSld>
@@ -10004,7 +10004,7 @@
           <p:cNvPr id="2" name="Shape 0">
             <a:extLst xmlns:a="http://schemas.openxmlformats.org/drawingml/2006/main">
               <a:ext uri="{FF2B5EF4-FFF2-40B4-BE49-F238E27FC236}">
-                <a16:creationId xmlns:a16="http://schemas.microsoft.com/office/drawing/2014/main" id="{719AA2BE-B6C1-4F7F-8EAA-25721E164D48}"/>
+                <a16:creationId xmlns:a16="http://schemas.microsoft.com/office/drawing/2014/main" id="{142F9E38-91BD-4544-BB88-E30C5F7E0FDB}"/>
               </a:ext>
             </a:extLst>
           </p:cNvPr>
@@ -10037,7 +10037,7 @@
           <p:cNvPr id="3" name="Text 1">
             <a:extLst xmlns:a="http://schemas.openxmlformats.org/drawingml/2006/main">
               <a:ext uri="{FF2B5EF4-FFF2-40B4-BE49-F238E27FC236}">
-                <a16:creationId xmlns:a16="http://schemas.microsoft.com/office/drawing/2014/main" id="{367CBADB-9987-4292-B7A7-E43D4F321F77}"/>
+                <a16:creationId xmlns:a16="http://schemas.microsoft.com/office/drawing/2014/main" id="{BBB5795F-9A65-4334-A6BD-9AA8827B9762}"/>
               </a:ext>
             </a:extLst>
           </p:cNvPr>
@@ -10084,7 +10084,7 @@
           <p:cNvPr id="4" name="Text 2">
             <a:extLst xmlns:a="http://schemas.openxmlformats.org/drawingml/2006/main">
               <a:ext uri="{FF2B5EF4-FFF2-40B4-BE49-F238E27FC236}">
-                <a16:creationId xmlns:a16="http://schemas.microsoft.com/office/drawing/2014/main" id="{DE19D9D2-D90C-4B69-BB54-B598F0B47CC7}"/>
+                <a16:creationId xmlns:a16="http://schemas.microsoft.com/office/drawing/2014/main" id="{5CC159D8-2D62-428E-9B7B-A068BFAF7B38}"/>
               </a:ext>
             </a:extLst>
           </p:cNvPr>
@@ -10131,7 +10131,7 @@
           <p:cNvPr id="5" name="Shape 3">
             <a:extLst xmlns:a="http://schemas.openxmlformats.org/drawingml/2006/main">
               <a:ext uri="{FF2B5EF4-FFF2-40B4-BE49-F238E27FC236}">
-                <a16:creationId xmlns:a16="http://schemas.microsoft.com/office/drawing/2014/main" id="{A9A785C2-38A5-4119-AAEF-B31DEE2EA4F2}"/>
+                <a16:creationId xmlns:a16="http://schemas.microsoft.com/office/drawing/2014/main" id="{9012564D-0BC7-4AE5-837F-BDD724B91245}"/>
               </a:ext>
             </a:extLst>
           </p:cNvPr>
@@ -10162,7 +10162,7 @@
           <p:cNvPr id="6" name="Text 4">
             <a:extLst xmlns:a="http://schemas.openxmlformats.org/drawingml/2006/main">
               <a:ext uri="{FF2B5EF4-FFF2-40B4-BE49-F238E27FC236}">
-                <a16:creationId xmlns:a16="http://schemas.microsoft.com/office/drawing/2014/main" id="{0B8859CF-05A8-4E3D-BE6B-BEAAB7A8AA2B}"/>
+                <a16:creationId xmlns:a16="http://schemas.microsoft.com/office/drawing/2014/main" id="{A75D1BF4-1697-461E-AB18-C8AE0D001CF3}"/>
               </a:ext>
             </a:extLst>
           </p:cNvPr>
@@ -10253,7 +10253,7 @@
           <p:cNvPr id="7" name="Text 5">
             <a:extLst xmlns:a="http://schemas.openxmlformats.org/drawingml/2006/main">
               <a:ext uri="{FF2B5EF4-FFF2-40B4-BE49-F238E27FC236}">
-                <a16:creationId xmlns:a16="http://schemas.microsoft.com/office/drawing/2014/main" id="{F6E7BCD2-DC5D-407B-96E3-DCA4EBEF295D}"/>
+                <a16:creationId xmlns:a16="http://schemas.microsoft.com/office/drawing/2014/main" id="{77619F36-4AE5-4224-827A-628B5D35369D}"/>
               </a:ext>
             </a:extLst>
           </p:cNvPr>
@@ -10344,7 +10344,7 @@
           <p:cNvPr id="8" name="Text 6">
             <a:extLst xmlns:a="http://schemas.openxmlformats.org/drawingml/2006/main">
               <a:ext uri="{FF2B5EF4-FFF2-40B4-BE49-F238E27FC236}">
-                <a16:creationId xmlns:a16="http://schemas.microsoft.com/office/drawing/2014/main" id="{8DDD7040-9D09-4E62-93B2-CFF4C7265435}"/>
+                <a16:creationId xmlns:a16="http://schemas.microsoft.com/office/drawing/2014/main" id="{D565EC05-6A68-418A-83D1-B9DA6D25AFAD}"/>
               </a:ext>
             </a:extLst>
           </p:cNvPr>
@@ -10435,7 +10435,7 @@
           <p:cNvPr id="9" name="Text 7">
             <a:extLst xmlns:a="http://schemas.openxmlformats.org/drawingml/2006/main">
               <a:ext uri="{FF2B5EF4-FFF2-40B4-BE49-F238E27FC236}">
-                <a16:creationId xmlns:a16="http://schemas.microsoft.com/office/drawing/2014/main" id="{478CD714-9806-46B6-A080-33DD70BDCC9B}"/>
+                <a16:creationId xmlns:a16="http://schemas.microsoft.com/office/drawing/2014/main" id="{9426D6F0-4001-4FA6-8491-B97FAC158E54}"/>
               </a:ext>
             </a:extLst>
           </p:cNvPr>
@@ -10508,7 +10508,7 @@
     </p:spTree>
     <p:extLst>
       <p:ext uri="{BB962C8B-B14F-4D97-AF65-F5344CB8AC3E}">
-        <p14:creationId xmlns:p14="http://schemas.microsoft.com/office/powerpoint/2010/main" val="1116608800"/>
+        <p14:creationId xmlns:p14="http://schemas.microsoft.com/office/powerpoint/2010/main" val="1632966200"/>
       </p:ext>
     </p:extLst>
   </p:cSld>
@@ -10539,7 +10539,7 @@
           <p:cNvPr id="2" name="Shape 0">
             <a:extLst xmlns:a="http://schemas.openxmlformats.org/drawingml/2006/main">
               <a:ext uri="{FF2B5EF4-FFF2-40B4-BE49-F238E27FC236}">
-                <a16:creationId xmlns:a16="http://schemas.microsoft.com/office/drawing/2014/main" id="{69372D84-67DB-414F-BEE0-BCAC006716AB}"/>
+                <a16:creationId xmlns:a16="http://schemas.microsoft.com/office/drawing/2014/main" id="{0AE6DB79-7DBD-44DB-9AB7-5EA147F9253C}"/>
               </a:ext>
             </a:extLst>
           </p:cNvPr>
@@ -10572,7 +10572,7 @@
           <p:cNvPr id="3" name="Text 1">
             <a:extLst xmlns:a="http://schemas.openxmlformats.org/drawingml/2006/main">
               <a:ext uri="{FF2B5EF4-FFF2-40B4-BE49-F238E27FC236}">
-                <a16:creationId xmlns:a16="http://schemas.microsoft.com/office/drawing/2014/main" id="{78DD4BB6-9CB3-4480-B916-EBA3ED350167}"/>
+                <a16:creationId xmlns:a16="http://schemas.microsoft.com/office/drawing/2014/main" id="{2BCD5B7A-0EA2-4E80-8C11-76608F253D68}"/>
               </a:ext>
             </a:extLst>
           </p:cNvPr>
@@ -10619,7 +10619,7 @@
           <p:cNvPr id="4" name="Text 2">
             <a:extLst xmlns:a="http://schemas.openxmlformats.org/drawingml/2006/main">
               <a:ext uri="{FF2B5EF4-FFF2-40B4-BE49-F238E27FC236}">
-                <a16:creationId xmlns:a16="http://schemas.microsoft.com/office/drawing/2014/main" id="{D2E935ED-24AC-41CF-BA54-C6EC6DEA7A56}"/>
+                <a16:creationId xmlns:a16="http://schemas.microsoft.com/office/drawing/2014/main" id="{14CFECF6-94A1-42D7-9CA4-CA14A5EFC448}"/>
               </a:ext>
             </a:extLst>
           </p:cNvPr>
@@ -10666,7 +10666,7 @@
           <p:cNvPr id="5" name="Shape 3">
             <a:extLst xmlns:a="http://schemas.openxmlformats.org/drawingml/2006/main">
               <a:ext uri="{FF2B5EF4-FFF2-40B4-BE49-F238E27FC236}">
-                <a16:creationId xmlns:a16="http://schemas.microsoft.com/office/drawing/2014/main" id="{9D2E949F-B6A2-42EE-876B-CD271761BFCD}"/>
+                <a16:creationId xmlns:a16="http://schemas.microsoft.com/office/drawing/2014/main" id="{0F8F6021-B157-4F7F-9CE2-6F774F8ED47C}"/>
               </a:ext>
             </a:extLst>
           </p:cNvPr>
@@ -10697,7 +10697,7 @@
           <p:cNvPr id="6" name="Text 4">
             <a:extLst xmlns:a="http://schemas.openxmlformats.org/drawingml/2006/main">
               <a:ext uri="{FF2B5EF4-FFF2-40B4-BE49-F238E27FC236}">
-                <a16:creationId xmlns:a16="http://schemas.microsoft.com/office/drawing/2014/main" id="{A80208EA-4FFD-4269-BA4D-E81E14F59C72}"/>
+                <a16:creationId xmlns:a16="http://schemas.microsoft.com/office/drawing/2014/main" id="{47881374-A4F5-4F21-9865-67E544180D76}"/>
               </a:ext>
             </a:extLst>
           </p:cNvPr>
@@ -10820,7 +10820,7 @@
           <p:cNvPr id="7" name="Text 5">
             <a:extLst xmlns:a="http://schemas.openxmlformats.org/drawingml/2006/main">
               <a:ext uri="{FF2B5EF4-FFF2-40B4-BE49-F238E27FC236}">
-                <a16:creationId xmlns:a16="http://schemas.microsoft.com/office/drawing/2014/main" id="{4E8B83D7-B727-48B2-BB8A-49F5272F3166}"/>
+                <a16:creationId xmlns:a16="http://schemas.microsoft.com/office/drawing/2014/main" id="{8FD54585-2131-493C-93AE-D4357D7119EB}"/>
               </a:ext>
             </a:extLst>
           </p:cNvPr>
@@ -10994,7 +10994,7 @@
     </p:spTree>
     <p:extLst>
       <p:ext uri="{BB962C8B-B14F-4D97-AF65-F5344CB8AC3E}">
-        <p14:creationId xmlns:p14="http://schemas.microsoft.com/office/powerpoint/2010/main" val="30628246"/>
+        <p14:creationId xmlns:p14="http://schemas.microsoft.com/office/powerpoint/2010/main" val="1782337803"/>
       </p:ext>
     </p:extLst>
   </p:cSld>
@@ -11025,7 +11025,7 @@
           <p:cNvPr id="2" name="Shape 0">
             <a:extLst xmlns:a="http://schemas.openxmlformats.org/drawingml/2006/main">
               <a:ext uri="{FF2B5EF4-FFF2-40B4-BE49-F238E27FC236}">
-                <a16:creationId xmlns:a16="http://schemas.microsoft.com/office/drawing/2014/main" id="{517BA8A4-F761-4C32-A981-4C547A5268E3}"/>
+                <a16:creationId xmlns:a16="http://schemas.microsoft.com/office/drawing/2014/main" id="{9ED1A2A3-4A3E-42DF-BD89-E36DFE6A7AD7}"/>
               </a:ext>
             </a:extLst>
           </p:cNvPr>
@@ -11058,7 +11058,7 @@
           <p:cNvPr id="3" name="Text 1">
             <a:extLst xmlns:a="http://schemas.openxmlformats.org/drawingml/2006/main">
               <a:ext uri="{FF2B5EF4-FFF2-40B4-BE49-F238E27FC236}">
-                <a16:creationId xmlns:a16="http://schemas.microsoft.com/office/drawing/2014/main" id="{AFC9E89E-C50A-4BE6-9493-C8AC7E9115B8}"/>
+                <a16:creationId xmlns:a16="http://schemas.microsoft.com/office/drawing/2014/main" id="{5C85846C-DC2C-4DD5-AF5E-72BDF124D256}"/>
               </a:ext>
             </a:extLst>
           </p:cNvPr>
@@ -11105,7 +11105,7 @@
           <p:cNvPr id="4" name="Text 2">
             <a:extLst xmlns:a="http://schemas.openxmlformats.org/drawingml/2006/main">
               <a:ext uri="{FF2B5EF4-FFF2-40B4-BE49-F238E27FC236}">
-                <a16:creationId xmlns:a16="http://schemas.microsoft.com/office/drawing/2014/main" id="{5DD34149-29A6-42D5-806D-EEC410B0F002}"/>
+                <a16:creationId xmlns:a16="http://schemas.microsoft.com/office/drawing/2014/main" id="{5553BDA6-7846-4E65-A0E6-69E70008049B}"/>
               </a:ext>
             </a:extLst>
           </p:cNvPr>
@@ -11152,7 +11152,7 @@
           <p:cNvPr id="5" name="Shape 3">
             <a:extLst xmlns:a="http://schemas.openxmlformats.org/drawingml/2006/main">
               <a:ext uri="{FF2B5EF4-FFF2-40B4-BE49-F238E27FC236}">
-                <a16:creationId xmlns:a16="http://schemas.microsoft.com/office/drawing/2014/main" id="{EF5FE6C3-DCB9-4E41-B869-C1AAB43E7E2A}"/>
+                <a16:creationId xmlns:a16="http://schemas.microsoft.com/office/drawing/2014/main" id="{F68F2517-6A8A-48B7-9213-57DD4B22A525}"/>
               </a:ext>
             </a:extLst>
           </p:cNvPr>
@@ -11183,7 +11183,7 @@
           <p:cNvPr id="6" name="Text 4">
             <a:extLst xmlns:a="http://schemas.openxmlformats.org/drawingml/2006/main">
               <a:ext uri="{FF2B5EF4-FFF2-40B4-BE49-F238E27FC236}">
-                <a16:creationId xmlns:a16="http://schemas.microsoft.com/office/drawing/2014/main" id="{E2C431C5-3DA6-4065-AD87-CBE932EFE2B4}"/>
+                <a16:creationId xmlns:a16="http://schemas.microsoft.com/office/drawing/2014/main" id="{9B7CE2D7-DA00-4D0B-8206-6A3A29BA789B}"/>
               </a:ext>
             </a:extLst>
           </p:cNvPr>
@@ -11258,7 +11258,7 @@
           <p:cNvPr id="7" name="Text 5">
             <a:extLst xmlns:a="http://schemas.openxmlformats.org/drawingml/2006/main">
               <a:ext uri="{FF2B5EF4-FFF2-40B4-BE49-F238E27FC236}">
-                <a16:creationId xmlns:a16="http://schemas.microsoft.com/office/drawing/2014/main" id="{9907E7F2-CCEA-4193-B037-0AA62E00EAA3}"/>
+                <a16:creationId xmlns:a16="http://schemas.microsoft.com/office/drawing/2014/main" id="{FD2229B2-1863-498F-8EFF-0293FB341695}"/>
               </a:ext>
             </a:extLst>
           </p:cNvPr>
@@ -11333,7 +11333,7 @@
           <p:cNvPr id="8" name="Text 6">
             <a:extLst xmlns:a="http://schemas.openxmlformats.org/drawingml/2006/main">
               <a:ext uri="{FF2B5EF4-FFF2-40B4-BE49-F238E27FC236}">
-                <a16:creationId xmlns:a16="http://schemas.microsoft.com/office/drawing/2014/main" id="{1BEE358A-4C0F-4F47-9FF7-315EA47F529E}"/>
+                <a16:creationId xmlns:a16="http://schemas.microsoft.com/office/drawing/2014/main" id="{0C7ACB9E-83E2-41C7-8E05-82CBE206670D}"/>
               </a:ext>
             </a:extLst>
           </p:cNvPr>
@@ -11408,7 +11408,7 @@
           <p:cNvPr id="9" name="Text 7">
             <a:extLst xmlns:a="http://schemas.openxmlformats.org/drawingml/2006/main">
               <a:ext uri="{FF2B5EF4-FFF2-40B4-BE49-F238E27FC236}">
-                <a16:creationId xmlns:a16="http://schemas.microsoft.com/office/drawing/2014/main" id="{0EFCCABA-3BF2-4B66-8689-AE652119107A}"/>
+                <a16:creationId xmlns:a16="http://schemas.microsoft.com/office/drawing/2014/main" id="{D89CE76B-0EC5-4F55-865F-8F62829727FD}"/>
               </a:ext>
             </a:extLst>
           </p:cNvPr>
@@ -11483,7 +11483,7 @@
           <p:cNvPr id="10" name="Text 8">
             <a:extLst xmlns:a="http://schemas.openxmlformats.org/drawingml/2006/main">
               <a:ext uri="{FF2B5EF4-FFF2-40B4-BE49-F238E27FC236}">
-                <a16:creationId xmlns:a16="http://schemas.microsoft.com/office/drawing/2014/main" id="{941DA292-1351-4A56-9C38-9145E5B2B8B8}"/>
+                <a16:creationId xmlns:a16="http://schemas.microsoft.com/office/drawing/2014/main" id="{F4F6F1C5-250A-4C93-9794-B2914D96CE71}"/>
               </a:ext>
             </a:extLst>
           </p:cNvPr>
@@ -11556,7 +11556,7 @@
     </p:spTree>
     <p:extLst>
       <p:ext uri="{BB962C8B-B14F-4D97-AF65-F5344CB8AC3E}">
-        <p14:creationId xmlns:p14="http://schemas.microsoft.com/office/powerpoint/2010/main" val="2083256189"/>
+        <p14:creationId xmlns:p14="http://schemas.microsoft.com/office/powerpoint/2010/main" val="313031475"/>
       </p:ext>
     </p:extLst>
   </p:cSld>
@@ -11587,7 +11587,7 @@
           <p:cNvPr id="2" name="Shape 0">
             <a:extLst xmlns:a="http://schemas.openxmlformats.org/drawingml/2006/main">
               <a:ext uri="{FF2B5EF4-FFF2-40B4-BE49-F238E27FC236}">
-                <a16:creationId xmlns:a16="http://schemas.microsoft.com/office/drawing/2014/main" id="{2AC22075-536C-4245-BAE4-FF1FDDBD2576}"/>
+                <a16:creationId xmlns:a16="http://schemas.microsoft.com/office/drawing/2014/main" id="{EF05CE59-8586-416E-A214-F1A29D24B4A2}"/>
               </a:ext>
             </a:extLst>
           </p:cNvPr>
@@ -11620,7 +11620,7 @@
           <p:cNvPr id="3" name="Text 1">
             <a:extLst xmlns:a="http://schemas.openxmlformats.org/drawingml/2006/main">
               <a:ext uri="{FF2B5EF4-FFF2-40B4-BE49-F238E27FC236}">
-                <a16:creationId xmlns:a16="http://schemas.microsoft.com/office/drawing/2014/main" id="{5F293E89-E216-4A7F-9013-1582E464DAB9}"/>
+                <a16:creationId xmlns:a16="http://schemas.microsoft.com/office/drawing/2014/main" id="{79F5DE80-4AA9-4066-B297-42AFA77BF12D}"/>
               </a:ext>
             </a:extLst>
           </p:cNvPr>
@@ -11667,7 +11667,7 @@
           <p:cNvPr id="4" name="Text 2">
             <a:extLst xmlns:a="http://schemas.openxmlformats.org/drawingml/2006/main">
               <a:ext uri="{FF2B5EF4-FFF2-40B4-BE49-F238E27FC236}">
-                <a16:creationId xmlns:a16="http://schemas.microsoft.com/office/drawing/2014/main" id="{4776B2C1-A9EF-4BFA-8D33-C506F35DA3D3}"/>
+                <a16:creationId xmlns:a16="http://schemas.microsoft.com/office/drawing/2014/main" id="{5F0E1CD9-FE97-4610-BBD2-6B8E1462B567}"/>
               </a:ext>
             </a:extLst>
           </p:cNvPr>
@@ -11714,7 +11714,7 @@
           <p:cNvPr id="5" name="Shape 3">
             <a:extLst xmlns:a="http://schemas.openxmlformats.org/drawingml/2006/main">
               <a:ext uri="{FF2B5EF4-FFF2-40B4-BE49-F238E27FC236}">
-                <a16:creationId xmlns:a16="http://schemas.microsoft.com/office/drawing/2014/main" id="{E5C3A455-F8AC-48D4-9FE3-D286B8EB8865}"/>
+                <a16:creationId xmlns:a16="http://schemas.microsoft.com/office/drawing/2014/main" id="{D8381FAD-2D94-4354-88A4-8405DA3D8B48}"/>
               </a:ext>
             </a:extLst>
           </p:cNvPr>
@@ -11745,7 +11745,7 @@
           <p:cNvPr id="6" name="Text 4">
             <a:extLst xmlns:a="http://schemas.openxmlformats.org/drawingml/2006/main">
               <a:ext uri="{FF2B5EF4-FFF2-40B4-BE49-F238E27FC236}">
-                <a16:creationId xmlns:a16="http://schemas.microsoft.com/office/drawing/2014/main" id="{80A6A3D2-7033-46FB-8974-78A1E558DAF7}"/>
+                <a16:creationId xmlns:a16="http://schemas.microsoft.com/office/drawing/2014/main" id="{E90AAFE9-0400-4C04-9890-1DFE0DFDA5AC}"/>
               </a:ext>
             </a:extLst>
           </p:cNvPr>
@@ -11884,7 +11884,7 @@
           <p:cNvPr id="7" name="Text 5">
             <a:extLst xmlns:a="http://schemas.openxmlformats.org/drawingml/2006/main">
               <a:ext uri="{FF2B5EF4-FFF2-40B4-BE49-F238E27FC236}">
-                <a16:creationId xmlns:a16="http://schemas.microsoft.com/office/drawing/2014/main" id="{E5DD0F45-3EBD-41F9-BB7A-1C903B931F0D}"/>
+                <a16:creationId xmlns:a16="http://schemas.microsoft.com/office/drawing/2014/main" id="{1859B74A-95F9-4427-9219-8B3CABB3034B}"/>
               </a:ext>
             </a:extLst>
           </p:cNvPr>
@@ -12079,7 +12079,7 @@
     </p:spTree>
     <p:extLst>
       <p:ext uri="{BB962C8B-B14F-4D97-AF65-F5344CB8AC3E}">
-        <p14:creationId xmlns:p14="http://schemas.microsoft.com/office/powerpoint/2010/main" val="761851040"/>
+        <p14:creationId xmlns:p14="http://schemas.microsoft.com/office/powerpoint/2010/main" val="266498798"/>
       </p:ext>
     </p:extLst>
   </p:cSld>
@@ -12110,7 +12110,7 @@
           <p:cNvPr id="2" name="Shape 0">
             <a:extLst xmlns:a="http://schemas.openxmlformats.org/drawingml/2006/main">
               <a:ext uri="{FF2B5EF4-FFF2-40B4-BE49-F238E27FC236}">
-                <a16:creationId xmlns:a16="http://schemas.microsoft.com/office/drawing/2014/main" id="{D82623C6-5BAB-425D-9589-DA80758F0A06}"/>
+                <a16:creationId xmlns:a16="http://schemas.microsoft.com/office/drawing/2014/main" id="{8E7A5641-9A87-4C27-8C28-33C0948192A1}"/>
               </a:ext>
             </a:extLst>
           </p:cNvPr>
@@ -12143,7 +12143,7 @@
           <p:cNvPr id="3" name="Text 1">
             <a:extLst xmlns:a="http://schemas.openxmlformats.org/drawingml/2006/main">
               <a:ext uri="{FF2B5EF4-FFF2-40B4-BE49-F238E27FC236}">
-                <a16:creationId xmlns:a16="http://schemas.microsoft.com/office/drawing/2014/main" id="{C5E9D3A5-BE91-4C9B-B6CB-FD21C06543D2}"/>
+                <a16:creationId xmlns:a16="http://schemas.microsoft.com/office/drawing/2014/main" id="{558B40FB-B176-461E-A867-BF2EF2AB6710}"/>
               </a:ext>
             </a:extLst>
           </p:cNvPr>
@@ -12190,7 +12190,7 @@
           <p:cNvPr id="4" name="Text 2">
             <a:extLst xmlns:a="http://schemas.openxmlformats.org/drawingml/2006/main">
               <a:ext uri="{FF2B5EF4-FFF2-40B4-BE49-F238E27FC236}">
-                <a16:creationId xmlns:a16="http://schemas.microsoft.com/office/drawing/2014/main" id="{AA97B1C9-C748-4508-B524-14AB06E10E7E}"/>
+                <a16:creationId xmlns:a16="http://schemas.microsoft.com/office/drawing/2014/main" id="{D595350F-5F3A-49E6-B116-6E0684521197}"/>
               </a:ext>
             </a:extLst>
           </p:cNvPr>
@@ -12237,7 +12237,7 @@
           <p:cNvPr id="5" name="Shape 3">
             <a:extLst xmlns:a="http://schemas.openxmlformats.org/drawingml/2006/main">
               <a:ext uri="{FF2B5EF4-FFF2-40B4-BE49-F238E27FC236}">
-                <a16:creationId xmlns:a16="http://schemas.microsoft.com/office/drawing/2014/main" id="{3AE3BD2B-A312-4764-8C6B-9D2D41F10033}"/>
+                <a16:creationId xmlns:a16="http://schemas.microsoft.com/office/drawing/2014/main" id="{0E287F93-9128-40F3-9684-6535F727AAC5}"/>
               </a:ext>
             </a:extLst>
           </p:cNvPr>
@@ -12268,7 +12268,7 @@
           <p:cNvPr id="6" name="Text 4">
             <a:extLst xmlns:a="http://schemas.openxmlformats.org/drawingml/2006/main">
               <a:ext uri="{FF2B5EF4-FFF2-40B4-BE49-F238E27FC236}">
-                <a16:creationId xmlns:a16="http://schemas.microsoft.com/office/drawing/2014/main" id="{1B2B5E43-308C-4BDE-AFC6-5A2E29F24C96}"/>
+                <a16:creationId xmlns:a16="http://schemas.microsoft.com/office/drawing/2014/main" id="{5F5F6A63-C260-4E93-BACE-54C7E0B6B9B8}"/>
               </a:ext>
             </a:extLst>
           </p:cNvPr>
@@ -12391,7 +12391,7 @@
           <p:cNvPr id="7" name="Text 5">
             <a:extLst xmlns:a="http://schemas.openxmlformats.org/drawingml/2006/main">
               <a:ext uri="{FF2B5EF4-FFF2-40B4-BE49-F238E27FC236}">
-                <a16:creationId xmlns:a16="http://schemas.microsoft.com/office/drawing/2014/main" id="{4D85C288-A8E8-48BA-B9AC-B009A3D568D1}"/>
+                <a16:creationId xmlns:a16="http://schemas.microsoft.com/office/drawing/2014/main" id="{447DE5AA-85DE-45D9-8CD7-172773A9675D}"/>
               </a:ext>
             </a:extLst>
           </p:cNvPr>
@@ -12572,7 +12572,7 @@
           <p:cNvPr id="8" name="Text 6">
             <a:extLst xmlns:a="http://schemas.openxmlformats.org/drawingml/2006/main">
               <a:ext uri="{FF2B5EF4-FFF2-40B4-BE49-F238E27FC236}">
-                <a16:creationId xmlns:a16="http://schemas.microsoft.com/office/drawing/2014/main" id="{0CCDC439-8387-4F6B-AFCC-55A4223A52B7}"/>
+                <a16:creationId xmlns:a16="http://schemas.microsoft.com/office/drawing/2014/main" id="{ED15484B-9DA4-4824-AFB0-60641EC651D8}"/>
               </a:ext>
             </a:extLst>
           </p:cNvPr>
@@ -12617,7 +12617,7 @@
     </p:spTree>
     <p:extLst>
       <p:ext uri="{BB962C8B-B14F-4D97-AF65-F5344CB8AC3E}">
-        <p14:creationId xmlns:p14="http://schemas.microsoft.com/office/powerpoint/2010/main" val="1713150317"/>
+        <p14:creationId xmlns:p14="http://schemas.microsoft.com/office/powerpoint/2010/main" val="1733397235"/>
       </p:ext>
     </p:extLst>
   </p:cSld>
@@ -12648,7 +12648,7 @@
           <p:cNvPr id="2" name="Shape 0">
             <a:extLst xmlns:a="http://schemas.openxmlformats.org/drawingml/2006/main">
               <a:ext uri="{FF2B5EF4-FFF2-40B4-BE49-F238E27FC236}">
-                <a16:creationId xmlns:a16="http://schemas.microsoft.com/office/drawing/2014/main" id="{2DDE7F87-9A29-43E4-8EDB-A1BC18AA4BF2}"/>
+                <a16:creationId xmlns:a16="http://schemas.microsoft.com/office/drawing/2014/main" id="{6E9B2926-269C-40CC-B85B-A14C63EAF4AF}"/>
               </a:ext>
             </a:extLst>
           </p:cNvPr>
@@ -12681,7 +12681,7 @@
           <p:cNvPr id="3" name="Text 1">
             <a:extLst xmlns:a="http://schemas.openxmlformats.org/drawingml/2006/main">
               <a:ext uri="{FF2B5EF4-FFF2-40B4-BE49-F238E27FC236}">
-                <a16:creationId xmlns:a16="http://schemas.microsoft.com/office/drawing/2014/main" id="{8768C627-02AD-4DE2-BA95-DEDB3B8D062D}"/>
+                <a16:creationId xmlns:a16="http://schemas.microsoft.com/office/drawing/2014/main" id="{D9634A4D-4BD7-4083-A8D8-83AE9CFD806E}"/>
               </a:ext>
             </a:extLst>
           </p:cNvPr>
@@ -12728,7 +12728,7 @@
           <p:cNvPr id="4" name="Text 2">
             <a:extLst xmlns:a="http://schemas.openxmlformats.org/drawingml/2006/main">
               <a:ext uri="{FF2B5EF4-FFF2-40B4-BE49-F238E27FC236}">
-                <a16:creationId xmlns:a16="http://schemas.microsoft.com/office/drawing/2014/main" id="{461D5C99-B269-48DE-9EFC-1E2AD93BDF57}"/>
+                <a16:creationId xmlns:a16="http://schemas.microsoft.com/office/drawing/2014/main" id="{AF654089-2CB8-4BCF-8586-A754D9E379BD}"/>
               </a:ext>
             </a:extLst>
           </p:cNvPr>
@@ -12775,7 +12775,7 @@
           <p:cNvPr id="5" name="Shape 3">
             <a:extLst xmlns:a="http://schemas.openxmlformats.org/drawingml/2006/main">
               <a:ext uri="{FF2B5EF4-FFF2-40B4-BE49-F238E27FC236}">
-                <a16:creationId xmlns:a16="http://schemas.microsoft.com/office/drawing/2014/main" id="{2EA62E40-F31C-4E72-886D-C2B689D454DB}"/>
+                <a16:creationId xmlns:a16="http://schemas.microsoft.com/office/drawing/2014/main" id="{BB30D9CA-0271-4C2D-BD1C-D8DB6D8AD801}"/>
               </a:ext>
             </a:extLst>
           </p:cNvPr>
@@ -12806,7 +12806,7 @@
           <p:cNvPr id="6" name="Text 4">
             <a:extLst xmlns:a="http://schemas.openxmlformats.org/drawingml/2006/main">
               <a:ext uri="{FF2B5EF4-FFF2-40B4-BE49-F238E27FC236}">
-                <a16:creationId xmlns:a16="http://schemas.microsoft.com/office/drawing/2014/main" id="{4FB19DD9-F919-454F-847D-73F9E9DFF9DC}"/>
+                <a16:creationId xmlns:a16="http://schemas.microsoft.com/office/drawing/2014/main" id="{1DC6B552-4F88-4119-8080-7976FB7FBC61}"/>
               </a:ext>
             </a:extLst>
           </p:cNvPr>
@@ -12929,7 +12929,7 @@
           <p:cNvPr id="7" name="Text 5">
             <a:extLst xmlns:a="http://schemas.openxmlformats.org/drawingml/2006/main">
               <a:ext uri="{FF2B5EF4-FFF2-40B4-BE49-F238E27FC236}">
-                <a16:creationId xmlns:a16="http://schemas.microsoft.com/office/drawing/2014/main" id="{BA329F4B-BA51-4973-8DE1-AF5D5841F0CF}"/>
+                <a16:creationId xmlns:a16="http://schemas.microsoft.com/office/drawing/2014/main" id="{3991ADE2-81D4-4DBE-BD29-DCD7B7C3EE77}"/>
               </a:ext>
             </a:extLst>
           </p:cNvPr>
@@ -13124,7 +13124,7 @@
     </p:spTree>
     <p:extLst>
       <p:ext uri="{BB962C8B-B14F-4D97-AF65-F5344CB8AC3E}">
-        <p14:creationId xmlns:p14="http://schemas.microsoft.com/office/powerpoint/2010/main" val="889958140"/>
+        <p14:creationId xmlns:p14="http://schemas.microsoft.com/office/powerpoint/2010/main" val="1070039726"/>
       </p:ext>
     </p:extLst>
   </p:cSld>
@@ -13155,7 +13155,7 @@
           <p:cNvPr id="2" name="Shape 0">
             <a:extLst xmlns:a="http://schemas.openxmlformats.org/drawingml/2006/main">
               <a:ext uri="{FF2B5EF4-FFF2-40B4-BE49-F238E27FC236}">
-                <a16:creationId xmlns:a16="http://schemas.microsoft.com/office/drawing/2014/main" id="{4CD6FE12-B785-4634-AC42-7F85E1D43CC6}"/>
+                <a16:creationId xmlns:a16="http://schemas.microsoft.com/office/drawing/2014/main" id="{60FD56E8-F27E-407D-AF29-FA3B99A6EE4C}"/>
               </a:ext>
             </a:extLst>
           </p:cNvPr>
@@ -13188,7 +13188,7 @@
           <p:cNvPr id="3" name="Text 1">
             <a:extLst xmlns:a="http://schemas.openxmlformats.org/drawingml/2006/main">
               <a:ext uri="{FF2B5EF4-FFF2-40B4-BE49-F238E27FC236}">
-                <a16:creationId xmlns:a16="http://schemas.microsoft.com/office/drawing/2014/main" id="{4B44CB74-0496-4B0C-ABA0-05EA1989B343}"/>
+                <a16:creationId xmlns:a16="http://schemas.microsoft.com/office/drawing/2014/main" id="{B52244FE-833D-430A-882A-4BB0C19B6371}"/>
               </a:ext>
             </a:extLst>
           </p:cNvPr>
@@ -13235,7 +13235,7 @@
           <p:cNvPr id="4" name="Text 2">
             <a:extLst xmlns:a="http://schemas.openxmlformats.org/drawingml/2006/main">
               <a:ext uri="{FF2B5EF4-FFF2-40B4-BE49-F238E27FC236}">
-                <a16:creationId xmlns:a16="http://schemas.microsoft.com/office/drawing/2014/main" id="{224543C7-2502-4374-8C80-44AE13694D03}"/>
+                <a16:creationId xmlns:a16="http://schemas.microsoft.com/office/drawing/2014/main" id="{023D65F1-7A9D-43D8-882B-C684E13BA5E7}"/>
               </a:ext>
             </a:extLst>
           </p:cNvPr>
@@ -13282,7 +13282,7 @@
           <p:cNvPr id="5" name="Shape 3">
             <a:extLst xmlns:a="http://schemas.openxmlformats.org/drawingml/2006/main">
               <a:ext uri="{FF2B5EF4-FFF2-40B4-BE49-F238E27FC236}">
-                <a16:creationId xmlns:a16="http://schemas.microsoft.com/office/drawing/2014/main" id="{6DEA5B36-45D7-4F8D-B8FE-8F4E865F777E}"/>
+                <a16:creationId xmlns:a16="http://schemas.microsoft.com/office/drawing/2014/main" id="{4917B85C-A147-44B4-A3E0-B50C378441FD}"/>
               </a:ext>
             </a:extLst>
           </p:cNvPr>
@@ -13313,7 +13313,7 @@
           <p:cNvPr id="6" name="Text 4">
             <a:extLst xmlns:a="http://schemas.openxmlformats.org/drawingml/2006/main">
               <a:ext uri="{FF2B5EF4-FFF2-40B4-BE49-F238E27FC236}">
-                <a16:creationId xmlns:a16="http://schemas.microsoft.com/office/drawing/2014/main" id="{CC3BC258-8CC2-431E-A146-AC0AEAB27E4E}"/>
+                <a16:creationId xmlns:a16="http://schemas.microsoft.com/office/drawing/2014/main" id="{995F001B-3697-4615-A99F-5294F34320A5}"/>
               </a:ext>
             </a:extLst>
           </p:cNvPr>
@@ -13436,7 +13436,7 @@
           <p:cNvPr id="7" name="Text 5">
             <a:extLst xmlns:a="http://schemas.openxmlformats.org/drawingml/2006/main">
               <a:ext uri="{FF2B5EF4-FFF2-40B4-BE49-F238E27FC236}">
-                <a16:creationId xmlns:a16="http://schemas.microsoft.com/office/drawing/2014/main" id="{14D23E66-C075-4257-861A-B8A12B71175E}"/>
+                <a16:creationId xmlns:a16="http://schemas.microsoft.com/office/drawing/2014/main" id="{ED0E843B-74E7-4AF8-855D-AF620A244A41}"/>
               </a:ext>
             </a:extLst>
           </p:cNvPr>
@@ -13631,7 +13631,7 @@
     </p:spTree>
     <p:extLst>
       <p:ext uri="{BB962C8B-B14F-4D97-AF65-F5344CB8AC3E}">
-        <p14:creationId xmlns:p14="http://schemas.microsoft.com/office/powerpoint/2010/main" val="1653111394"/>
+        <p14:creationId xmlns:p14="http://schemas.microsoft.com/office/powerpoint/2010/main" val="121270463"/>
       </p:ext>
     </p:extLst>
   </p:cSld>

</xml_diff>